<commit_message>
Refine ATDT lead positioning language
</commit_message>
<xml_diff>
--- a/leads/juan-carlos-bautista-jacobo/call-prep-bautista-jacobo-atdt.pptx
+++ b/leads/juan-carlos-bautista-jacobo/call-prep-bautista-jacobo-atdt.pptx
@@ -4,6 +4,9 @@
   <p:sldMasterIdLst>
     <p:sldMasterId id="2147483648" r:id="rId1"/>
   </p:sldMasterIdLst>
+  <p:notesMasterIdLst>
+    <p:notesMasterId r:id="rId11"/>
+  </p:notesMasterIdLst>
   <p:sldIdLst>
     <p:sldId id="256" r:id="rId2"/>
     <p:sldId id="257" r:id="rId3"/>
@@ -15,10 +18,7 @@
     <p:sldId id="263" r:id="rId9"/>
     <p:sldId id="264" r:id="rId10"/>
   </p:sldIdLst>
-  <p:notesMasterIdLst>
-    <p:notesMasterId r:id="rId11"/>
-  </p:notesMasterIdLst>
-  <p:sldSz cx="9144000" cy="5143500"/>
+  <p:sldSz cx="9144000" cy="5143500" type="screen16x9"/>
   <p:notesSz cx="5143500" cy="9144000"/>
   <p:defaultTextStyle>
     <a:lvl1pPr marL="0" algn="l" defTabSz="914400" rtl="0" eaLnBrk="1" latinLnBrk="0" hangingPunct="1">
@@ -112,7 +112,275 @@
       </a:defRPr>
     </a:lvl9pPr>
   </p:defaultTextStyle>
+  <p:extLst>
+    <p:ext uri="{EFAFB233-063F-42B5-8137-9DF3F51BA10A}">
+      <p15:sldGuideLst xmlns:p15="http://schemas.microsoft.com/office/powerpoint/2012/main"/>
+    </p:ext>
+  </p:extLst>
 </p:presentation>
+</file>
+
+<file path=ppt/changesInfos/changesInfo1.xml><?xml version="1.0" encoding="utf-8"?>
+<pc:chgInfo xmlns:a="http://schemas.openxmlformats.org/drawingml/2006/main" xmlns:r="http://schemas.openxmlformats.org/officeDocument/2006/relationships" xmlns:ac="http://schemas.microsoft.com/office/drawing/2013/main/command" xmlns:pc="http://schemas.microsoft.com/office/powerpoint/2013/main/command">
+  <pc:docChgLst>
+    <pc:chgData name="Juan Carlos Arias" userId="516c89d14e59d458" providerId="LiveId" clId="{21CA5D15-785A-486F-9325-D036C4009284}"/>
+    <pc:docChg chg="custSel modSld">
+      <pc:chgData name="Juan Carlos Arias" userId="516c89d14e59d458" providerId="LiveId" clId="{21CA5D15-785A-486F-9325-D036C4009284}" dt="2026-05-22T03:38:21.134" v="28" actId="20577"/>
+      <pc:docMkLst>
+        <pc:docMk/>
+      </pc:docMkLst>
+      <pc:sldChg chg="modSp mod">
+        <pc:chgData name="Juan Carlos Arias" userId="516c89d14e59d458" providerId="LiveId" clId="{21CA5D15-785A-486F-9325-D036C4009284}" dt="2026-05-22T03:38:19.729" v="26" actId="20577"/>
+        <pc:sldMkLst>
+          <pc:docMk/>
+          <pc:sldMk cId="0" sldId="258"/>
+        </pc:sldMkLst>
+        <pc:spChg chg="mod">
+          <ac:chgData name="Juan Carlos Arias" userId="516c89d14e59d458" providerId="LiveId" clId="{21CA5D15-785A-486F-9325-D036C4009284}" dt="2026-05-22T03:35:59.599" v="0" actId="20577"/>
+          <ac:spMkLst>
+            <pc:docMk/>
+            <pc:sldMk cId="0" sldId="258"/>
+            <ac:spMk id="3" creationId="{00000000-0000-0000-0000-000000000000}"/>
+          </ac:spMkLst>
+        </pc:spChg>
+        <pc:spChg chg="mod">
+          <ac:chgData name="Juan Carlos Arias" userId="516c89d14e59d458" providerId="LiveId" clId="{21CA5D15-785A-486F-9325-D036C4009284}" dt="2026-05-22T03:35:59.774" v="1" actId="20577"/>
+          <ac:spMkLst>
+            <pc:docMk/>
+            <pc:sldMk cId="0" sldId="258"/>
+            <ac:spMk id="7" creationId="{00000000-0000-0000-0000-000000000000}"/>
+          </ac:spMkLst>
+        </pc:spChg>
+        <pc:spChg chg="mod">
+          <ac:chgData name="Juan Carlos Arias" userId="516c89d14e59d458" providerId="LiveId" clId="{21CA5D15-785A-486F-9325-D036C4009284}" dt="2026-05-22T03:38:19.729" v="26" actId="20577"/>
+          <ac:spMkLst>
+            <pc:docMk/>
+            <pc:sldMk cId="0" sldId="258"/>
+            <ac:spMk id="11" creationId="{00000000-0000-0000-0000-000000000000}"/>
+          </ac:spMkLst>
+        </pc:spChg>
+      </pc:sldChg>
+      <pc:sldChg chg="modSp mod">
+        <pc:chgData name="Juan Carlos Arias" userId="516c89d14e59d458" providerId="LiveId" clId="{21CA5D15-785A-486F-9325-D036C4009284}" dt="2026-05-22T03:38:20.482" v="27" actId="20577"/>
+        <pc:sldMkLst>
+          <pc:docMk/>
+          <pc:sldMk cId="0" sldId="259"/>
+        </pc:sldMkLst>
+        <pc:spChg chg="mod">
+          <ac:chgData name="Juan Carlos Arias" userId="516c89d14e59d458" providerId="LiveId" clId="{21CA5D15-785A-486F-9325-D036C4009284}" dt="2026-05-22T03:36:00.237" v="3" actId="20577"/>
+          <ac:spMkLst>
+            <pc:docMk/>
+            <pc:sldMk cId="0" sldId="259"/>
+            <ac:spMk id="6" creationId="{00000000-0000-0000-0000-000000000000}"/>
+          </ac:spMkLst>
+        </pc:spChg>
+        <pc:spChg chg="mod">
+          <ac:chgData name="Juan Carlos Arias" userId="516c89d14e59d458" providerId="LiveId" clId="{21CA5D15-785A-486F-9325-D036C4009284}" dt="2026-05-22T03:36:00.310" v="4" actId="20577"/>
+          <ac:spMkLst>
+            <pc:docMk/>
+            <pc:sldMk cId="0" sldId="259"/>
+            <ac:spMk id="7" creationId="{00000000-0000-0000-0000-000000000000}"/>
+          </ac:spMkLst>
+        </pc:spChg>
+        <pc:spChg chg="mod">
+          <ac:chgData name="Juan Carlos Arias" userId="516c89d14e59d458" providerId="LiveId" clId="{21CA5D15-785A-486F-9325-D036C4009284}" dt="2026-05-22T03:36:00.444" v="5" actId="20577"/>
+          <ac:spMkLst>
+            <pc:docMk/>
+            <pc:sldMk cId="0" sldId="259"/>
+            <ac:spMk id="10" creationId="{00000000-0000-0000-0000-000000000000}"/>
+          </ac:spMkLst>
+        </pc:spChg>
+        <pc:spChg chg="mod">
+          <ac:chgData name="Juan Carlos Arias" userId="516c89d14e59d458" providerId="LiveId" clId="{21CA5D15-785A-486F-9325-D036C4009284}" dt="2026-05-22T03:36:00.518" v="6" actId="20577"/>
+          <ac:spMkLst>
+            <pc:docMk/>
+            <pc:sldMk cId="0" sldId="259"/>
+            <ac:spMk id="11" creationId="{00000000-0000-0000-0000-000000000000}"/>
+          </ac:spMkLst>
+        </pc:spChg>
+        <pc:spChg chg="mod">
+          <ac:chgData name="Juan Carlos Arias" userId="516c89d14e59d458" providerId="LiveId" clId="{21CA5D15-785A-486F-9325-D036C4009284}" dt="2026-05-22T03:38:20.482" v="27" actId="20577"/>
+          <ac:spMkLst>
+            <pc:docMk/>
+            <pc:sldMk cId="0" sldId="259"/>
+            <ac:spMk id="19" creationId="{00000000-0000-0000-0000-000000000000}"/>
+          </ac:spMkLst>
+        </pc:spChg>
+      </pc:sldChg>
+      <pc:sldChg chg="modSp mod">
+        <pc:chgData name="Juan Carlos Arias" userId="516c89d14e59d458" providerId="LiveId" clId="{21CA5D15-785A-486F-9325-D036C4009284}" dt="2026-05-22T03:38:21.134" v="28" actId="20577"/>
+        <pc:sldMkLst>
+          <pc:docMk/>
+          <pc:sldMk cId="0" sldId="260"/>
+        </pc:sldMkLst>
+        <pc:spChg chg="mod">
+          <ac:chgData name="Juan Carlos Arias" userId="516c89d14e59d458" providerId="LiveId" clId="{21CA5D15-785A-486F-9325-D036C4009284}" dt="2026-05-22T03:36:01.682" v="8" actId="20577"/>
+          <ac:spMkLst>
+            <pc:docMk/>
+            <pc:sldMk cId="0" sldId="260"/>
+            <ac:spMk id="11" creationId="{00000000-0000-0000-0000-000000000000}"/>
+          </ac:spMkLst>
+        </pc:spChg>
+        <pc:spChg chg="mod">
+          <ac:chgData name="Juan Carlos Arias" userId="516c89d14e59d458" providerId="LiveId" clId="{21CA5D15-785A-486F-9325-D036C4009284}" dt="2026-05-22T03:38:21.134" v="28" actId="20577"/>
+          <ac:spMkLst>
+            <pc:docMk/>
+            <pc:sldMk cId="0" sldId="260"/>
+            <ac:spMk id="14" creationId="{00000000-0000-0000-0000-000000000000}"/>
+          </ac:spMkLst>
+        </pc:spChg>
+        <pc:spChg chg="mod">
+          <ac:chgData name="Juan Carlos Arias" userId="516c89d14e59d458" providerId="LiveId" clId="{21CA5D15-785A-486F-9325-D036C4009284}" dt="2026-05-22T03:36:01.889" v="10" actId="20577"/>
+          <ac:spMkLst>
+            <pc:docMk/>
+            <pc:sldMk cId="0" sldId="260"/>
+            <ac:spMk id="15" creationId="{00000000-0000-0000-0000-000000000000}"/>
+          </ac:spMkLst>
+        </pc:spChg>
+        <pc:spChg chg="mod">
+          <ac:chgData name="Juan Carlos Arias" userId="516c89d14e59d458" providerId="LiveId" clId="{21CA5D15-785A-486F-9325-D036C4009284}" dt="2026-05-22T03:36:02.015" v="11" actId="20577"/>
+          <ac:spMkLst>
+            <pc:docMk/>
+            <pc:sldMk cId="0" sldId="260"/>
+            <ac:spMk id="18" creationId="{00000000-0000-0000-0000-000000000000}"/>
+          </ac:spMkLst>
+        </pc:spChg>
+        <pc:spChg chg="mod">
+          <ac:chgData name="Juan Carlos Arias" userId="516c89d14e59d458" providerId="LiveId" clId="{21CA5D15-785A-486F-9325-D036C4009284}" dt="2026-05-22T03:36:02.085" v="12" actId="20577"/>
+          <ac:spMkLst>
+            <pc:docMk/>
+            <pc:sldMk cId="0" sldId="260"/>
+            <ac:spMk id="19" creationId="{00000000-0000-0000-0000-000000000000}"/>
+          </ac:spMkLst>
+        </pc:spChg>
+      </pc:sldChg>
+      <pc:sldChg chg="modSp mod">
+        <pc:chgData name="Juan Carlos Arias" userId="516c89d14e59d458" providerId="LiveId" clId="{21CA5D15-785A-486F-9325-D036C4009284}" dt="2026-05-22T03:36:02.559" v="14" actId="20577"/>
+        <pc:sldMkLst>
+          <pc:docMk/>
+          <pc:sldMk cId="0" sldId="261"/>
+        </pc:sldMkLst>
+        <pc:spChg chg="mod">
+          <ac:chgData name="Juan Carlos Arias" userId="516c89d14e59d458" providerId="LiveId" clId="{21CA5D15-785A-486F-9325-D036C4009284}" dt="2026-05-22T03:36:02.380" v="13" actId="20577"/>
+          <ac:spMkLst>
+            <pc:docMk/>
+            <pc:sldMk cId="0" sldId="261"/>
+            <ac:spMk id="7" creationId="{00000000-0000-0000-0000-000000000000}"/>
+          </ac:spMkLst>
+        </pc:spChg>
+        <pc:spChg chg="mod">
+          <ac:chgData name="Juan Carlos Arias" userId="516c89d14e59d458" providerId="LiveId" clId="{21CA5D15-785A-486F-9325-D036C4009284}" dt="2026-05-22T03:36:02.559" v="14" actId="20577"/>
+          <ac:spMkLst>
+            <pc:docMk/>
+            <pc:sldMk cId="0" sldId="261"/>
+            <ac:spMk id="11" creationId="{00000000-0000-0000-0000-000000000000}"/>
+          </ac:spMkLst>
+        </pc:spChg>
+      </pc:sldChg>
+      <pc:sldChg chg="modSp mod">
+        <pc:chgData name="Juan Carlos Arias" userId="516c89d14e59d458" providerId="LiveId" clId="{21CA5D15-785A-486F-9325-D036C4009284}" dt="2026-05-22T03:36:03.530" v="17" actId="20577"/>
+        <pc:sldMkLst>
+          <pc:docMk/>
+          <pc:sldMk cId="0" sldId="262"/>
+        </pc:sldMkLst>
+        <pc:spChg chg="mod">
+          <ac:chgData name="Juan Carlos Arias" userId="516c89d14e59d458" providerId="LiveId" clId="{21CA5D15-785A-486F-9325-D036C4009284}" dt="2026-05-22T03:36:02.911" v="15" actId="20577"/>
+          <ac:spMkLst>
+            <pc:docMk/>
+            <pc:sldMk cId="0" sldId="262"/>
+            <ac:spMk id="7" creationId="{00000000-0000-0000-0000-000000000000}"/>
+          </ac:spMkLst>
+        </pc:spChg>
+        <pc:spChg chg="mod">
+          <ac:chgData name="Juan Carlos Arias" userId="516c89d14e59d458" providerId="LiveId" clId="{21CA5D15-785A-486F-9325-D036C4009284}" dt="2026-05-22T03:36:03.139" v="16" actId="20577"/>
+          <ac:spMkLst>
+            <pc:docMk/>
+            <pc:sldMk cId="0" sldId="262"/>
+            <ac:spMk id="11" creationId="{00000000-0000-0000-0000-000000000000}"/>
+          </ac:spMkLst>
+        </pc:spChg>
+        <pc:spChg chg="mod">
+          <ac:chgData name="Juan Carlos Arias" userId="516c89d14e59d458" providerId="LiveId" clId="{21CA5D15-785A-486F-9325-D036C4009284}" dt="2026-05-22T03:36:03.530" v="17" actId="20577"/>
+          <ac:spMkLst>
+            <pc:docMk/>
+            <pc:sldMk cId="0" sldId="262"/>
+            <ac:spMk id="19" creationId="{00000000-0000-0000-0000-000000000000}"/>
+          </ac:spMkLst>
+        </pc:spChg>
+      </pc:sldChg>
+      <pc:sldChg chg="modSp mod">
+        <pc:chgData name="Juan Carlos Arias" userId="516c89d14e59d458" providerId="LiveId" clId="{21CA5D15-785A-486F-9325-D036C4009284}" dt="2026-05-22T03:36:04.429" v="21" actId="20577"/>
+        <pc:sldMkLst>
+          <pc:docMk/>
+          <pc:sldMk cId="0" sldId="263"/>
+        </pc:sldMkLst>
+        <pc:spChg chg="mod">
+          <ac:chgData name="Juan Carlos Arias" userId="516c89d14e59d458" providerId="LiveId" clId="{21CA5D15-785A-486F-9325-D036C4009284}" dt="2026-05-22T03:36:03.912" v="18" actId="20577"/>
+          <ac:spMkLst>
+            <pc:docMk/>
+            <pc:sldMk cId="0" sldId="263"/>
+            <ac:spMk id="8" creationId="{00000000-0000-0000-0000-000000000000}"/>
+          </ac:spMkLst>
+        </pc:spChg>
+        <pc:spChg chg="mod">
+          <ac:chgData name="Juan Carlos Arias" userId="516c89d14e59d458" providerId="LiveId" clId="{21CA5D15-785A-486F-9325-D036C4009284}" dt="2026-05-22T03:36:03.985" v="19" actId="20577"/>
+          <ac:spMkLst>
+            <pc:docMk/>
+            <pc:sldMk cId="0" sldId="263"/>
+            <ac:spMk id="9" creationId="{00000000-0000-0000-0000-000000000000}"/>
+          </ac:spMkLst>
+        </pc:spChg>
+        <pc:spChg chg="mod">
+          <ac:chgData name="Juan Carlos Arias" userId="516c89d14e59d458" providerId="LiveId" clId="{21CA5D15-785A-486F-9325-D036C4009284}" dt="2026-05-22T03:36:04.363" v="20" actId="20577"/>
+          <ac:spMkLst>
+            <pc:docMk/>
+            <pc:sldMk cId="0" sldId="263"/>
+            <ac:spMk id="17" creationId="{00000000-0000-0000-0000-000000000000}"/>
+          </ac:spMkLst>
+        </pc:spChg>
+        <pc:spChg chg="mod">
+          <ac:chgData name="Juan Carlos Arias" userId="516c89d14e59d458" providerId="LiveId" clId="{21CA5D15-785A-486F-9325-D036C4009284}" dt="2026-05-22T03:36:04.429" v="21" actId="20577"/>
+          <ac:spMkLst>
+            <pc:docMk/>
+            <pc:sldMk cId="0" sldId="263"/>
+            <ac:spMk id="18" creationId="{00000000-0000-0000-0000-000000000000}"/>
+          </ac:spMkLst>
+        </pc:spChg>
+      </pc:sldChg>
+      <pc:sldChg chg="modSp mod">
+        <pc:chgData name="Juan Carlos Arias" userId="516c89d14e59d458" providerId="LiveId" clId="{21CA5D15-785A-486F-9325-D036C4009284}" dt="2026-05-22T03:36:05.100" v="24" actId="20577"/>
+        <pc:sldMkLst>
+          <pc:docMk/>
+          <pc:sldMk cId="0" sldId="264"/>
+        </pc:sldMkLst>
+        <pc:spChg chg="mod">
+          <ac:chgData name="Juan Carlos Arias" userId="516c89d14e59d458" providerId="LiveId" clId="{21CA5D15-785A-486F-9325-D036C4009284}" dt="2026-05-22T03:36:04.771" v="22" actId="20577"/>
+          <ac:spMkLst>
+            <pc:docMk/>
+            <pc:sldMk cId="0" sldId="264"/>
+            <ac:spMk id="5" creationId="{00000000-0000-0000-0000-000000000000}"/>
+          </ac:spMkLst>
+        </pc:spChg>
+        <pc:spChg chg="mod">
+          <ac:chgData name="Juan Carlos Arias" userId="516c89d14e59d458" providerId="LiveId" clId="{21CA5D15-785A-486F-9325-D036C4009284}" dt="2026-05-22T03:36:04.963" v="23" actId="20577"/>
+          <ac:spMkLst>
+            <pc:docMk/>
+            <pc:sldMk cId="0" sldId="264"/>
+            <ac:spMk id="9" creationId="{00000000-0000-0000-0000-000000000000}"/>
+          </ac:spMkLst>
+        </pc:spChg>
+        <pc:spChg chg="mod">
+          <ac:chgData name="Juan Carlos Arias" userId="516c89d14e59d458" providerId="LiveId" clId="{21CA5D15-785A-486F-9325-D036C4009284}" dt="2026-05-22T03:36:05.100" v="24" actId="20577"/>
+          <ac:spMkLst>
+            <pc:docMk/>
+            <pc:sldMk cId="0" sldId="264"/>
+            <ac:spMk id="12" creationId="{00000000-0000-0000-0000-000000000000}"/>
+          </ac:spMkLst>
+        </pc:spChg>
+      </pc:sldChg>
+    </pc:docChg>
+  </pc:docChgLst>
+</pc:chgInfo>
 </file>
 
 <file path=ppt/notesMasters/notesMaster1.xml><?xml version="1.0" encoding="utf-8"?>
@@ -137,234 +405,10 @@
           <a:chExt cx="0" cy="0"/>
         </a:xfrm>
       </p:grpSpPr>
-      <p:sp>
-        <p:nvSpPr>
-          <p:cNvPr id="2" name="Header Placeholder 1"/>
-          <p:cNvSpPr>
-            <a:spLocks noGrp="1"/>
-          </p:cNvSpPr>
-          <p:nvPr>
-            <p:ph type="hdr" sz="quarter"/>
-          </p:nvPr>
-        </p:nvSpPr>
-        <p:spPr>
-          <a:xfrm>
-            <a:off x="0" y="0"/>
-            <a:ext cx="2971800" cy="458788"/>
-          </a:xfrm>
-          <a:prstGeom prst="rect">
-            <a:avLst/>
-          </a:prstGeom>
-        </p:spPr>
-        <p:txBody>
-          <a:bodyPr vert="horz" lIns="91440" tIns="45720" rIns="91440" bIns="45720" rtlCol="0"/>
-          <a:lstStyle>
-            <a:lvl1pPr algn="l">
-              <a:defRPr sz="1200"/>
-            </a:lvl1pPr>
-          </a:lstStyle>
-          <a:p>
-            <a:endParaRPr lang="en-US"/>
-          </a:p>
-        </p:txBody>
-      </p:sp>
-      <p:sp>
-        <p:nvSpPr>
-          <p:cNvPr id="3" name="Date Placeholder 2"/>
-          <p:cNvSpPr>
-            <a:spLocks noGrp="1"/>
-          </p:cNvSpPr>
-          <p:nvPr>
-            <p:ph type="dt" idx="1"/>
-          </p:nvPr>
-        </p:nvSpPr>
-        <p:spPr>
-          <a:xfrm>
-            <a:off x="3884613" y="0"/>
-            <a:ext cx="2971800" cy="458788"/>
-          </a:xfrm>
-          <a:prstGeom prst="rect">
-            <a:avLst/>
-          </a:prstGeom>
-        </p:spPr>
-        <p:txBody>
-          <a:bodyPr vert="horz" lIns="91440" tIns="45720" rIns="91440" bIns="45720" rtlCol="0"/>
-          <a:lstStyle>
-            <a:lvl1pPr algn="r">
-              <a:defRPr sz="1200"/>
-            </a:lvl1pPr>
-          </a:lstStyle>
-          <a:p>
-            <a:fld id="{5282F153-3F37-0F45-9E97-73ACFA13230C}" type="datetimeFigureOut">
-              <a:rPr lang="en-US"/>
-              <a:t>7/23/19</a:t>
-            </a:fld>
-            <a:endParaRPr lang="en-US"/>
-          </a:p>
-        </p:txBody>
-      </p:sp>
-      <p:sp>
-        <p:nvSpPr>
-          <p:cNvPr id="4" name="Slide Image Placeholder 3"/>
-          <p:cNvSpPr>
-            <a:spLocks noGrp="1" noRot="1" noChangeAspect="1"/>
-          </p:cNvSpPr>
-          <p:nvPr>
-            <p:ph type="sldImg" idx="2"/>
-          </p:nvPr>
-        </p:nvSpPr>
-        <p:spPr>
-          <a:xfrm>
-            <a:off x="685800" y="1143000"/>
-            <a:ext cx="5486400" cy="3086100"/>
-          </a:xfrm>
-          <a:prstGeom prst="rect">
-            <a:avLst/>
-          </a:prstGeom>
-          <a:noFill/>
-          <a:ln w="12700">
-            <a:solidFill>
-              <a:prstClr val="black"/>
-            </a:solidFill>
-          </a:ln>
-        </p:spPr>
-        <p:txBody>
-          <a:bodyPr vert="horz" lIns="91440" tIns="45720" rIns="91440" bIns="45720" rtlCol="0" anchor="ctr"/>
-          <a:lstStyle/>
-          <a:p>
-            <a:endParaRPr lang="en-US"/>
-          </a:p>
-        </p:txBody>
-      </p:sp>
-      <p:sp>
-        <p:nvSpPr>
-          <p:cNvPr id="5" name="Notes Placeholder 4"/>
-          <p:cNvSpPr>
-            <a:spLocks noGrp="1"/>
-          </p:cNvSpPr>
-          <p:nvPr>
-            <p:ph type="body" sz="quarter" idx="3"/>
-          </p:nvPr>
-        </p:nvSpPr>
-        <p:spPr>
-          <a:xfrm>
-            <a:off x="685800" y="4400550"/>
-            <a:ext cx="5486400" cy="3600450"/>
-          </a:xfrm>
-          <a:prstGeom prst="rect">
-            <a:avLst/>
-          </a:prstGeom>
-        </p:spPr>
-        <p:txBody>
-          <a:bodyPr vert="horz" lIns="91440" tIns="45720" rIns="91440" bIns="45720" rtlCol="0"/>
-          <a:lstStyle/>
-          <a:p>
-            <a:pPr lvl="0"/>
-            <a:r>
-              <a:rPr lang="en-US"/>
-              <a:t>Click to edit Master text styles</a:t>
-            </a:r>
-          </a:p>
-          <a:p>
-            <a:pPr lvl="1"/>
-            <a:r>
-              <a:rPr lang="en-US"/>
-              <a:t>Second level</a:t>
-            </a:r>
-          </a:p>
-          <a:p>
-            <a:pPr lvl="2"/>
-            <a:r>
-              <a:rPr lang="en-US"/>
-              <a:t>Third level</a:t>
-            </a:r>
-          </a:p>
-          <a:p>
-            <a:pPr lvl="3"/>
-            <a:r>
-              <a:rPr lang="en-US"/>
-              <a:t>Fourth level</a:t>
-            </a:r>
-          </a:p>
-          <a:p>
-            <a:pPr lvl="4"/>
-            <a:r>
-              <a:rPr lang="en-US"/>
-              <a:t>Fifth level</a:t>
-            </a:r>
-          </a:p>
-        </p:txBody>
-      </p:sp>
-      <p:sp>
-        <p:nvSpPr>
-          <p:cNvPr id="6" name="Footer Placeholder 5"/>
-          <p:cNvSpPr>
-            <a:spLocks noGrp="1"/>
-          </p:cNvSpPr>
-          <p:nvPr>
-            <p:ph type="ftr" sz="quarter" idx="4"/>
-          </p:nvPr>
-        </p:nvSpPr>
-        <p:spPr>
-          <a:xfrm>
-            <a:off x="0" y="8685213"/>
-            <a:ext cx="2971800" cy="458787"/>
-          </a:xfrm>
-          <a:prstGeom prst="rect">
-            <a:avLst/>
-          </a:prstGeom>
-        </p:spPr>
-        <p:txBody>
-          <a:bodyPr vert="horz" lIns="91440" tIns="45720" rIns="91440" bIns="45720" rtlCol="0" anchor="b"/>
-          <a:lstStyle>
-            <a:lvl1pPr algn="l">
-              <a:defRPr sz="1200"/>
-            </a:lvl1pPr>
-          </a:lstStyle>
-          <a:p>
-            <a:endParaRPr lang="en-US"/>
-          </a:p>
-        </p:txBody>
-      </p:sp>
-      <p:sp>
-        <p:nvSpPr>
-          <p:cNvPr id="7" name="Slide Number Placeholder 6"/>
-          <p:cNvSpPr>
-            <a:spLocks noGrp="1"/>
-          </p:cNvSpPr>
-          <p:nvPr>
-            <p:ph type="sldNum" sz="quarter" idx="5"/>
-          </p:nvPr>
-        </p:nvSpPr>
-        <p:spPr>
-          <a:xfrm>
-            <a:off x="3884613" y="8685213"/>
-            <a:ext cx="2971800" cy="458787"/>
-          </a:xfrm>
-          <a:prstGeom prst="rect">
-            <a:avLst/>
-          </a:prstGeom>
-        </p:spPr>
-        <p:txBody>
-          <a:bodyPr vert="horz" lIns="91440" tIns="45720" rIns="91440" bIns="45720" rtlCol="0" anchor="b"/>
-          <a:lstStyle>
-            <a:lvl1pPr algn="r">
-              <a:defRPr sz="1200"/>
-            </a:lvl1pPr>
-          </a:lstStyle>
-          <a:p>
-            <a:fld id="{CE5E9CC1-C706-0F49-92D6-E571CC5EEA8F}" type="slidenum">
-              <a:rPr lang="en-US"/>
-              <a:t>‹#›</a:t>
-            </a:fld>
-            <a:endParaRPr lang="en-US"/>
-          </a:p>
-        </p:txBody>
-      </p:sp>
     </p:spTree>
     <p:extLst>
       <p:ext uri="{BB962C8B-B14F-4D97-AF65-F5344CB8AC3E}">
-        <p14:creationId xmlns:p14="http://schemas.microsoft.com/office/powerpoint/2010/main" val="1024086991"/>
+        <p14:creationId xmlns:p14="http://schemas.microsoft.com/office/powerpoint/2010/main" val="3441052743"/>
       </p:ext>
     </p:extLst>
   </p:cSld>
@@ -508,10 +552,6 @@
           <a:bodyPr/>
           <a:lstStyle/>
           <a:p>
-            <a:r>
-              <a:rPr lang="en-US" dirty="0"/>
-              <a:t/>
-            </a:r>
             <a:endParaRPr lang="en-US" dirty="0"/>
           </a:p>
         </p:txBody>
@@ -596,10 +636,6 @@
           <a:bodyPr/>
           <a:lstStyle/>
           <a:p>
-            <a:r>
-              <a:rPr lang="en-US" dirty="0"/>
-              <a:t/>
-            </a:r>
             <a:endParaRPr lang="en-US" dirty="0"/>
           </a:p>
         </p:txBody>
@@ -684,10 +720,6 @@
           <a:bodyPr/>
           <a:lstStyle/>
           <a:p>
-            <a:r>
-              <a:rPr lang="en-US" dirty="0"/>
-              <a:t/>
-            </a:r>
             <a:endParaRPr lang="en-US" dirty="0"/>
           </a:p>
         </p:txBody>
@@ -772,10 +804,6 @@
           <a:bodyPr/>
           <a:lstStyle/>
           <a:p>
-            <a:r>
-              <a:rPr lang="en-US" dirty="0"/>
-              <a:t/>
-            </a:r>
             <a:endParaRPr lang="en-US" dirty="0"/>
           </a:p>
         </p:txBody>
@@ -860,10 +888,6 @@
           <a:bodyPr/>
           <a:lstStyle/>
           <a:p>
-            <a:r>
-              <a:rPr lang="en-US" dirty="0"/>
-              <a:t/>
-            </a:r>
             <a:endParaRPr lang="en-US" dirty="0"/>
           </a:p>
         </p:txBody>
@@ -948,10 +972,6 @@
           <a:bodyPr/>
           <a:lstStyle/>
           <a:p>
-            <a:r>
-              <a:rPr lang="en-US" dirty="0"/>
-              <a:t/>
-            </a:r>
             <a:endParaRPr lang="en-US" dirty="0"/>
           </a:p>
         </p:txBody>
@@ -1036,10 +1056,6 @@
           <a:bodyPr/>
           <a:lstStyle/>
           <a:p>
-            <a:r>
-              <a:rPr lang="en-US" dirty="0"/>
-              <a:t/>
-            </a:r>
             <a:endParaRPr lang="en-US" dirty="0"/>
           </a:p>
         </p:txBody>
@@ -1124,10 +1140,6 @@
           <a:bodyPr/>
           <a:lstStyle/>
           <a:p>
-            <a:r>
-              <a:rPr lang="en-US" dirty="0"/>
-              <a:t/>
-            </a:r>
             <a:endParaRPr lang="en-US" dirty="0"/>
           </a:p>
         </p:txBody>
@@ -1212,10 +1224,6 @@
           <a:bodyPr/>
           <a:lstStyle/>
           <a:p>
-            <a:r>
-              <a:rPr lang="en-US" dirty="0"/>
-              <a:t/>
-            </a:r>
             <a:endParaRPr lang="en-US" dirty="0"/>
           </a:p>
         </p:txBody>
@@ -1289,6 +1297,11 @@
 <file path=ppt/slideMasters/slideMaster1.xml><?xml version="1.0" encoding="utf-8"?>
 <p:sldMaster xmlns:a="http://schemas.openxmlformats.org/drawingml/2006/main" xmlns:r="http://schemas.openxmlformats.org/officeDocument/2006/relationships" xmlns:p="http://schemas.openxmlformats.org/presentationml/2006/main">
   <p:cSld>
+    <p:bg>
+      <p:bgRef idx="1001">
+        <a:schemeClr val="bg1"/>
+      </p:bgRef>
+    </p:bg>
     <p:spTree>
       <p:nvGrpSpPr>
         <p:cNvPr id="1" name=""/>
@@ -1571,6 +1584,7 @@
         <a:solidFill>
           <a:srgbClr val="1B1A1B"/>
         </a:solidFill>
+        <a:effectLst/>
       </p:bgPr>
     </p:bg>
     <p:spTree>
@@ -1630,7 +1644,7 @@
           <a:bodyPr wrap="square" rtlCol="0" anchor="ctr"/>
           <a:lstStyle/>
           <a:p>
-            <a:pPr algn="ctr" indent="0" marL="0">
+            <a:pPr marL="0" indent="0" algn="ctr">
               <a:buNone/>
             </a:pPr>
             <a:r>
@@ -1669,7 +1683,7 @@
           <a:bodyPr wrap="square" lIns="0" tIns="0" rIns="0" bIns="0" rtlCol="0" anchor="ctr"/>
           <a:lstStyle/>
           <a:p>
-            <a:pPr indent="0" marL="0">
+            <a:pPr marL="0" indent="0">
               <a:buNone/>
             </a:pPr>
             <a:r>
@@ -1708,7 +1722,7 @@
           <a:bodyPr wrap="square" lIns="0" tIns="0" rIns="0" bIns="0" rtlCol="0" anchor="ctr"/>
           <a:lstStyle/>
           <a:p>
-            <a:pPr indent="0" marL="0">
+            <a:pPr marL="0" indent="0">
               <a:buNone/>
             </a:pPr>
             <a:r>
@@ -1747,7 +1761,7 @@
           <a:bodyPr wrap="square" lIns="0" tIns="0" rIns="0" bIns="0" rtlCol="0" anchor="ctr"/>
           <a:lstStyle/>
           <a:p>
-            <a:pPr indent="0" marL="0">
+            <a:pPr marL="0" indent="0">
               <a:buNone/>
             </a:pPr>
             <a:r>
@@ -1806,7 +1820,7 @@
           <a:bodyPr wrap="square" lIns="0" tIns="0" rIns="0" bIns="0" rtlCol="0" anchor="ctr"/>
           <a:lstStyle/>
           <a:p>
-            <a:pPr indent="0" marL="0">
+            <a:pPr marL="0" indent="0">
               <a:buNone/>
             </a:pPr>
             <a:r>
@@ -1845,7 +1859,7 @@
           <a:bodyPr wrap="square" lIns="0" tIns="0" rIns="0" bIns="0" rtlCol="0" anchor="ctr"/>
           <a:lstStyle/>
           <a:p>
-            <a:pPr algn="r" indent="0" marL="0">
+            <a:pPr marL="0" indent="0" algn="r">
               <a:buNone/>
             </a:pPr>
             <a:r>
@@ -1879,6 +1893,7 @@
         <a:solidFill>
           <a:srgbClr val="1B1A1B"/>
         </a:solidFill>
+        <a:effectLst/>
       </p:bgPr>
     </p:bg>
     <p:spTree>
@@ -1916,11 +1931,11 @@
           <a:bodyPr wrap="square" lIns="0" tIns="0" rIns="0" bIns="0" rtlCol="0" anchor="ctr"/>
           <a:lstStyle/>
           <a:p>
-            <a:pPr indent="0" marL="0">
-              <a:buNone/>
-            </a:pPr>
-            <a:r>
-              <a:rPr lang="en-US" sz="1000" b="1" spc="400" kern="0" dirty="0">
+            <a:pPr marL="0" indent="0">
+              <a:buNone/>
+            </a:pPr>
+            <a:r>
+              <a:rPr lang="en-US" sz="1000" b="1" kern="0" spc="400" dirty="0">
                 <a:solidFill>
                   <a:srgbClr val="A0A0A0"/>
                 </a:solidFill>
@@ -1955,7 +1970,7 @@
           <a:bodyPr wrap="square" lIns="0" tIns="0" rIns="0" bIns="0" rtlCol="0" anchor="ctr"/>
           <a:lstStyle/>
           <a:p>
-            <a:pPr indent="0" marL="0">
+            <a:pPr marL="0" indent="0">
               <a:buNone/>
             </a:pPr>
             <a:r>
@@ -1992,7 +2007,7 @@
           </a:solidFill>
           <a:ln/>
           <a:effectLst>
-            <a:outerShdw sx="100000" sy="100000" kx="0" ky="0" algn="bl" rotWithShape="0" blurRad="101600" dist="38100" dir="8100000">
+            <a:outerShdw blurRad="101600" dist="38100" dir="8100000" algn="bl" rotWithShape="0">
               <a:srgbClr val="000000">
                 <a:alpha val="30000"/>
               </a:srgbClr>
@@ -2021,11 +2036,11 @@
           <a:bodyPr wrap="square" lIns="0" tIns="0" rIns="0" bIns="0" rtlCol="0" anchor="ctr"/>
           <a:lstStyle/>
           <a:p>
-            <a:pPr indent="0" marL="0">
-              <a:buNone/>
-            </a:pPr>
-            <a:r>
-              <a:rPr lang="en-US" sz="900" b="1" spc="300" kern="0" dirty="0">
+            <a:pPr marL="0" indent="0">
+              <a:buNone/>
+            </a:pPr>
+            <a:r>
+              <a:rPr lang="en-US" sz="900" b="1" kern="0" spc="300" dirty="0">
                 <a:solidFill>
                   <a:srgbClr val="C8D8F8"/>
                 </a:solidFill>
@@ -2060,7 +2075,7 @@
           <a:bodyPr wrap="square" lIns="0" tIns="0" rIns="0" bIns="0" rtlCol="0" anchor="ctr"/>
           <a:lstStyle/>
           <a:p>
-            <a:pPr indent="0" marL="0">
+            <a:pPr marL="0" indent="0">
               <a:buNone/>
             </a:pPr>
             <a:r>
@@ -2099,7 +2114,7 @@
           <a:bodyPr wrap="square" lIns="0" tIns="0" rIns="0" bIns="0" rtlCol="0" anchor="ctr"/>
           <a:lstStyle/>
           <a:p>
-            <a:pPr indent="0" marL="0">
+            <a:pPr marL="0" indent="0">
               <a:buNone/>
             </a:pPr>
             <a:r>
@@ -2136,7 +2151,7 @@
           </a:solidFill>
           <a:ln/>
           <a:effectLst>
-            <a:outerShdw sx="100000" sy="100000" kx="0" ky="0" algn="bl" rotWithShape="0" blurRad="101600" dist="38100" dir="8100000">
+            <a:outerShdw blurRad="101600" dist="38100" dir="8100000" algn="bl" rotWithShape="0">
               <a:srgbClr val="000000">
                 <a:alpha val="30000"/>
               </a:srgbClr>
@@ -2165,11 +2180,11 @@
           <a:bodyPr wrap="square" lIns="0" tIns="0" rIns="0" bIns="0" rtlCol="0" anchor="ctr"/>
           <a:lstStyle/>
           <a:p>
-            <a:pPr indent="0" marL="0">
-              <a:buNone/>
-            </a:pPr>
-            <a:r>
-              <a:rPr lang="en-US" sz="900" b="1" spc="300" kern="0" dirty="0">
+            <a:pPr marL="0" indent="0">
+              <a:buNone/>
+            </a:pPr>
+            <a:r>
+              <a:rPr lang="en-US" sz="900" b="1" kern="0" spc="300" dirty="0">
                 <a:solidFill>
                   <a:srgbClr val="C8D8F8"/>
                 </a:solidFill>
@@ -2308,7 +2323,7 @@
           </a:solidFill>
           <a:ln/>
           <a:effectLst>
-            <a:outerShdw sx="100000" sy="100000" kx="0" ky="0" algn="bl" rotWithShape="0" blurRad="101600" dist="38100" dir="8100000">
+            <a:outerShdw blurRad="101600" dist="38100" dir="8100000" algn="bl" rotWithShape="0">
               <a:srgbClr val="000000">
                 <a:alpha val="30000"/>
               </a:srgbClr>
@@ -2337,11 +2352,11 @@
           <a:bodyPr wrap="square" lIns="0" tIns="0" rIns="0" bIns="0" rtlCol="0" anchor="ctr"/>
           <a:lstStyle/>
           <a:p>
-            <a:pPr indent="0" marL="0">
-              <a:buNone/>
-            </a:pPr>
-            <a:r>
-              <a:rPr lang="en-US" sz="900" b="1" spc="300" kern="0" dirty="0">
+            <a:pPr marL="0" indent="0">
+              <a:buNone/>
+            </a:pPr>
+            <a:r>
+              <a:rPr lang="en-US" sz="900" b="1" kern="0" spc="300" dirty="0">
                 <a:solidFill>
                   <a:srgbClr val="C8D8F8"/>
                 </a:solidFill>
@@ -2376,7 +2391,7 @@
           <a:bodyPr wrap="square" lIns="0" tIns="0" rIns="0" bIns="0" rtlCol="0" anchor="ctr"/>
           <a:lstStyle/>
           <a:p>
-            <a:pPr indent="0" marL="0">
+            <a:pPr marL="0" indent="0">
               <a:buNone/>
             </a:pPr>
             <a:r>
@@ -2415,7 +2430,7 @@
           <a:bodyPr wrap="square" lIns="0" tIns="0" rIns="0" bIns="0" rtlCol="0" anchor="ctr"/>
           <a:lstStyle/>
           <a:p>
-            <a:pPr indent="0" marL="0">
+            <a:pPr marL="0" indent="0">
               <a:buNone/>
             </a:pPr>
             <a:r>
@@ -2454,7 +2469,7 @@
           <a:bodyPr wrap="square" lIns="0" tIns="0" rIns="0" bIns="0" rtlCol="0" anchor="ctr"/>
           <a:lstStyle/>
           <a:p>
-            <a:pPr indent="0" marL="0">
+            <a:pPr marL="0" indent="0">
               <a:buNone/>
             </a:pPr>
             <a:r>
@@ -2493,7 +2508,7 @@
           <a:bodyPr wrap="square" lIns="0" tIns="0" rIns="0" bIns="0" rtlCol="0" anchor="ctr"/>
           <a:lstStyle/>
           <a:p>
-            <a:pPr algn="ctr" indent="0" marL="0">
+            <a:pPr marL="0" indent="0" algn="ctr">
               <a:buNone/>
             </a:pPr>
             <a:r>
@@ -2532,7 +2547,7 @@
           <a:bodyPr wrap="square" lIns="0" tIns="0" rIns="0" bIns="0" rtlCol="0" anchor="ctr"/>
           <a:lstStyle/>
           <a:p>
-            <a:pPr indent="0" marL="0">
+            <a:pPr marL="0" indent="0">
               <a:buNone/>
             </a:pPr>
             <a:r>
@@ -2571,7 +2586,7 @@
           <a:bodyPr wrap="square" lIns="0" tIns="0" rIns="0" bIns="0" rtlCol="0" anchor="ctr"/>
           <a:lstStyle/>
           <a:p>
-            <a:pPr indent="0" marL="0">
+            <a:pPr marL="0" indent="0">
               <a:buNone/>
             </a:pPr>
             <a:r>
@@ -2610,7 +2625,7 @@
           <a:bodyPr wrap="square" lIns="0" tIns="0" rIns="0" bIns="0" rtlCol="0" anchor="ctr"/>
           <a:lstStyle/>
           <a:p>
-            <a:pPr indent="0" marL="0">
+            <a:pPr marL="0" indent="0">
               <a:buNone/>
             </a:pPr>
             <a:r>
@@ -2649,7 +2664,7 @@
           <a:bodyPr wrap="square" lIns="0" tIns="0" rIns="0" bIns="0" rtlCol="0" anchor="ctr"/>
           <a:lstStyle/>
           <a:p>
-            <a:pPr algn="ctr" indent="0" marL="0">
+            <a:pPr marL="0" indent="0" algn="ctr">
               <a:buNone/>
             </a:pPr>
             <a:r>
@@ -2688,7 +2703,7 @@
           <a:bodyPr wrap="square" lIns="0" tIns="0" rIns="0" bIns="0" rtlCol="0" anchor="ctr"/>
           <a:lstStyle/>
           <a:p>
-            <a:pPr indent="0" marL="0">
+            <a:pPr marL="0" indent="0">
               <a:buNone/>
             </a:pPr>
             <a:r>
@@ -2727,7 +2742,7 @@
           <a:bodyPr wrap="square" lIns="0" tIns="0" rIns="0" bIns="0" rtlCol="0" anchor="ctr"/>
           <a:lstStyle/>
           <a:p>
-            <a:pPr indent="0" marL="0">
+            <a:pPr marL="0" indent="0">
               <a:buNone/>
             </a:pPr>
             <a:r>
@@ -2766,7 +2781,7 @@
           <a:bodyPr wrap="square" lIns="0" tIns="0" rIns="0" bIns="0" rtlCol="0" anchor="ctr"/>
           <a:lstStyle/>
           <a:p>
-            <a:pPr indent="0" marL="0">
+            <a:pPr marL="0" indent="0">
               <a:buNone/>
             </a:pPr>
             <a:r>
@@ -2800,6 +2815,7 @@
         <a:solidFill>
           <a:srgbClr val="1B1A1B"/>
         </a:solidFill>
+        <a:effectLst/>
       </p:bgPr>
     </p:bg>
     <p:spTree>
@@ -2837,11 +2853,11 @@
           <a:bodyPr wrap="square" lIns="0" tIns="0" rIns="0" bIns="0" rtlCol="0" anchor="ctr"/>
           <a:lstStyle/>
           <a:p>
-            <a:pPr indent="0" marL="0">
-              <a:buNone/>
-            </a:pPr>
-            <a:r>
-              <a:rPr lang="en-US" sz="1000" b="1" spc="400" kern="0" dirty="0">
+            <a:pPr marL="0" indent="0">
+              <a:buNone/>
+            </a:pPr>
+            <a:r>
+              <a:rPr lang="en-US" sz="1000" b="1" kern="0" spc="400" dirty="0">
                 <a:solidFill>
                   <a:srgbClr val="A0A0A0"/>
                 </a:solidFill>
@@ -2876,11 +2892,11 @@
           <a:bodyPr wrap="square" lIns="0" tIns="0" rIns="0" bIns="0" rtlCol="0" anchor="ctr"/>
           <a:lstStyle/>
           <a:p>
-            <a:pPr indent="0" marL="0">
-              <a:buNone/>
-            </a:pPr>
-            <a:r>
-              <a:rPr lang="en-US" sz="2200" dirty="0">
+            <a:pPr marL="0" indent="0">
+              <a:buNone/>
+            </a:pPr>
+            <a:r>
+              <a:rPr lang="es-ES" sz="2200">
                 <a:solidFill>
                   <a:srgbClr val="FFFFFF"/>
                 </a:solidFill>
@@ -2888,7 +2904,7 @@
                 <a:ea typeface="Source Sans Pro" pitchFamily="34" charset="-122"/>
                 <a:cs typeface="Source Sans Pro" pitchFamily="34" charset="-120"/>
               </a:rPr>
-              <a:t>Hablarle como arquitecto digital, no como funcionario de obras</a:t>
+              <a:t>Hablarle desde política pública digital, estándares nacionales e infraestructura replicable</a:t>
             </a:r>
             <a:endParaRPr lang="en-US" sz="2200" dirty="0"/>
           </a:p>
@@ -2913,7 +2929,7 @@
           </a:solidFill>
           <a:ln/>
           <a:effectLst>
-            <a:outerShdw sx="100000" sy="100000" kx="0" ky="0" algn="bl" rotWithShape="0" blurRad="101600" dist="38100" dir="8100000">
+            <a:outerShdw blurRad="101600" dist="38100" dir="8100000" algn="bl" rotWithShape="0">
               <a:srgbClr val="000000">
                 <a:alpha val="30000"/>
               </a:srgbClr>
@@ -2962,11 +2978,11 @@
           <a:bodyPr wrap="square" lIns="0" tIns="0" rIns="0" bIns="0" rtlCol="0" anchor="ctr"/>
           <a:lstStyle/>
           <a:p>
-            <a:pPr indent="0" marL="0">
-              <a:buNone/>
-            </a:pPr>
-            <a:r>
-              <a:rPr lang="en-US" sz="1000" b="1" spc="300" kern="0" dirty="0">
+            <a:pPr marL="0" indent="0">
+              <a:buNone/>
+            </a:pPr>
+            <a:r>
+              <a:rPr lang="en-US" sz="1000" b="1" kern="0" spc="300" dirty="0">
                 <a:solidFill>
                   <a:srgbClr val="4CAF50"/>
                 </a:solidFill>
@@ -3009,7 +3025,7 @@
               <a:buChar char="•"/>
             </a:pPr>
             <a:r>
-              <a:rPr lang="en-US" sz="1200" dirty="0">
+              <a:rPr lang="es-ES" sz="1200">
                 <a:solidFill>
                   <a:srgbClr val="FFFFFF"/>
                 </a:solidFill>
@@ -3017,9 +3033,8 @@
                 <a:ea typeface="Source Sans Pro" pitchFamily="34" charset="-122"/>
                 <a:cs typeface="Source Sans Pro" pitchFamily="34" charset="-120"/>
               </a:rPr>
-              <a:t>Una conversación entre pares sobre infraestructura digital de gobierno</a:t>
-            </a:r>
-            <a:endParaRPr lang="en-US" sz="1200" dirty="0"/>
+              <a:t>Una conversación sobre política pública digital, estándares nacionales e infraestructura replicable</a:t>
+            </a:r>
           </a:p>
           <a:p>
             <a:pPr marL="342900" indent="-342900">
@@ -3030,7 +3045,7 @@
               <a:buChar char="•"/>
             </a:pPr>
             <a:r>
-              <a:rPr lang="en-US" sz="1200" dirty="0">
+              <a:rPr lang="es-ES" sz="1200">
                 <a:solidFill>
                   <a:srgbClr val="FFFFFF"/>
                 </a:solidFill>
@@ -3038,9 +3053,8 @@
                 <a:ea typeface="Source Sans Pro" pitchFamily="34" charset="-122"/>
                 <a:cs typeface="Source Sans Pro" pitchFamily="34" charset="-120"/>
               </a:rPr>
-              <a:t>Una exploración de cómo nuestra plataforma podría ser un estándar federal replicable</a:t>
-            </a:r>
-            <a:endParaRPr lang="en-US" sz="1200" dirty="0"/>
+              <a:t>Una exploración de cómo experiencia probada puede traducirse en criterios y modelos replicables</a:t>
+            </a:r>
           </a:p>
           <a:p>
             <a:pPr marL="342900" indent="-342900">
@@ -3051,7 +3065,7 @@
               <a:buChar char="•"/>
             </a:pPr>
             <a:r>
-              <a:rPr lang="en-US" sz="1200" dirty="0">
+              <a:rPr lang="es-ES" sz="1200">
                 <a:solidFill>
                   <a:srgbClr val="FFFFFF"/>
                 </a:solidFill>
@@ -3061,7 +3075,6 @@
               </a:rPr>
               <a:t>Una oportunidad de entender las prioridades de la ATDT y dónde sumamos</a:t>
             </a:r>
-            <a:endParaRPr lang="en-US" sz="1200" dirty="0"/>
           </a:p>
           <a:p>
             <a:pPr marL="342900" indent="-342900">
@@ -3072,7 +3085,7 @@
               <a:buChar char="•"/>
             </a:pPr>
             <a:r>
-              <a:rPr lang="en-US" sz="1200" dirty="0">
+              <a:rPr lang="es-ES" sz="1200">
                 <a:solidFill>
                   <a:srgbClr val="FFFFFF"/>
                 </a:solidFill>
@@ -3105,7 +3118,7 @@
           </a:solidFill>
           <a:ln/>
           <a:effectLst>
-            <a:outerShdw sx="100000" sy="100000" kx="0" ky="0" algn="bl" rotWithShape="0" blurRad="101600" dist="38100" dir="8100000">
+            <a:outerShdw blurRad="101600" dist="38100" dir="8100000" algn="bl" rotWithShape="0">
               <a:srgbClr val="000000">
                 <a:alpha val="30000"/>
               </a:srgbClr>
@@ -3154,11 +3167,11 @@
           <a:bodyPr wrap="square" lIns="0" tIns="0" rIns="0" bIns="0" rtlCol="0" anchor="ctr"/>
           <a:lstStyle/>
           <a:p>
-            <a:pPr indent="0" marL="0">
-              <a:buNone/>
-            </a:pPr>
-            <a:r>
-              <a:rPr lang="en-US" sz="1000" b="1" spc="300" kern="0" dirty="0">
+            <a:pPr marL="0" indent="0">
+              <a:buNone/>
+            </a:pPr>
+            <a:r>
+              <a:rPr lang="en-US" sz="1000" b="1" kern="0" spc="300" dirty="0">
                 <a:solidFill>
                   <a:srgbClr val="E53935"/>
                 </a:solidFill>
@@ -3201,7 +3214,7 @@
               <a:buChar char="•"/>
             </a:pPr>
             <a:r>
-              <a:rPr lang="en-US" sz="1200" dirty="0">
+              <a:rPr lang="es-ES" sz="1200">
                 <a:solidFill>
                   <a:srgbClr val="FFFFFF"/>
                 </a:solidFill>
@@ -3209,9 +3222,8 @@
                 <a:ea typeface="Source Sans Pro" pitchFamily="34" charset="-122"/>
                 <a:cs typeface="Source Sans Pro" pitchFamily="34" charset="-120"/>
               </a:rPr>
-              <a:t>Un pitch de venta de software a gobierno</a:t>
-            </a:r>
-            <a:endParaRPr lang="en-US" sz="1200" dirty="0"/>
+              <a:t>Una venta de software ni una implementación local aislada</a:t>
+            </a:r>
           </a:p>
           <a:p>
             <a:pPr marL="342900" indent="-342900">
@@ -3222,7 +3234,7 @@
               <a:buChar char="•"/>
             </a:pPr>
             <a:r>
-              <a:rPr lang="en-US" sz="1200" dirty="0">
+              <a:rPr lang="es-ES" sz="1200">
                 <a:solidFill>
                   <a:srgbClr val="FFFFFF"/>
                 </a:solidFill>
@@ -3230,9 +3242,8 @@
                 <a:ea typeface="Source Sans Pro" pitchFamily="34" charset="-122"/>
                 <a:cs typeface="Source Sans Pro" pitchFamily="34" charset="-120"/>
               </a:rPr>
-              <a:t>Una presentación de 23 slides del PDF completo</a:t>
-            </a:r>
-            <a:endParaRPr lang="en-US" sz="1200" dirty="0"/>
+              <a:t>Una presentación completa del PDF</a:t>
+            </a:r>
           </a:p>
           <a:p>
             <a:pPr marL="342900" indent="-342900">
@@ -3243,7 +3254,7 @@
               <a:buChar char="•"/>
             </a:pPr>
             <a:r>
-              <a:rPr lang="en-US" sz="1200" dirty="0">
+              <a:rPr lang="es-ES" sz="1200">
                 <a:solidFill>
                   <a:srgbClr val="FFFFFF"/>
                 </a:solidFill>
@@ -3251,9 +3262,8 @@
                 <a:ea typeface="Source Sans Pro" pitchFamily="34" charset="-122"/>
                 <a:cs typeface="Source Sans Pro" pitchFamily="34" charset="-120"/>
               </a:rPr>
-              <a:t>Una propuesta para "tapar baches" — él no es de obras</a:t>
-            </a:r>
-            <a:endParaRPr lang="en-US" sz="1200" dirty="0"/>
+              <a:t>Una conversación centrada en baches, obra pública o ejecución operativa</a:t>
+            </a:r>
           </a:p>
           <a:p>
             <a:pPr marL="342900" indent="-342900">
@@ -3264,7 +3274,7 @@
               <a:buChar char="•"/>
             </a:pPr>
             <a:r>
-              <a:rPr lang="en-US" sz="1200" dirty="0">
+              <a:rPr lang="es-ES" sz="1200">
                 <a:solidFill>
                   <a:srgbClr val="FFFFFF"/>
                 </a:solidFill>
@@ -3272,7 +3282,7 @@
                 <a:ea typeface="Source Sans Pro" pitchFamily="34" charset="-122"/>
                 <a:cs typeface="Source Sans Pro" pitchFamily="34" charset="-120"/>
               </a:rPr>
-              <a:t>Una oferta para un municipio — él es nivel federal</a:t>
+              <a:t>Una propuesta local aislada — su rol es de política digital nacional</a:t>
             </a:r>
             <a:endParaRPr lang="en-US" sz="1200" dirty="0"/>
           </a:p>
@@ -3294,6 +3304,7 @@
         <a:solidFill>
           <a:srgbClr val="1B1A1B"/>
         </a:solidFill>
+        <a:effectLst/>
       </p:bgPr>
     </p:bg>
     <p:spTree>
@@ -3331,11 +3342,11 @@
           <a:bodyPr wrap="square" lIns="0" tIns="0" rIns="0" bIns="0" rtlCol="0" anchor="ctr"/>
           <a:lstStyle/>
           <a:p>
-            <a:pPr indent="0" marL="0">
-              <a:buNone/>
-            </a:pPr>
-            <a:r>
-              <a:rPr lang="en-US" sz="1000" b="1" spc="400" kern="0" dirty="0">
+            <a:pPr marL="0" indent="0">
+              <a:buNone/>
+            </a:pPr>
+            <a:r>
+              <a:rPr lang="en-US" sz="1000" b="1" kern="0" spc="400" dirty="0">
                 <a:solidFill>
                   <a:srgbClr val="4CAF50"/>
                 </a:solidFill>
@@ -3370,7 +3381,7 @@
           <a:bodyPr wrap="square" lIns="0" tIns="0" rIns="0" bIns="0" rtlCol="0" anchor="ctr"/>
           <a:lstStyle/>
           <a:p>
-            <a:pPr indent="0" marL="0">
+            <a:pPr marL="0" indent="0">
               <a:buNone/>
             </a:pPr>
             <a:r>
@@ -3429,7 +3440,7 @@
           <a:bodyPr wrap="square" lIns="0" tIns="0" rIns="0" bIns="0" rtlCol="0" anchor="ctr"/>
           <a:lstStyle/>
           <a:p>
-            <a:pPr algn="ctr" indent="0" marL="0">
+            <a:pPr marL="0" indent="0" algn="ctr">
               <a:buNone/>
             </a:pPr>
             <a:r>
@@ -3468,11 +3479,11 @@
           <a:bodyPr wrap="square" lIns="0" tIns="0" rIns="0" bIns="0" rtlCol="0" anchor="ctr"/>
           <a:lstStyle/>
           <a:p>
-            <a:pPr indent="0" marL="0">
-              <a:buNone/>
-            </a:pPr>
-            <a:r>
-              <a:rPr lang="en-US" sz="1500" b="1" dirty="0">
+            <a:pPr marL="0" indent="0">
+              <a:buNone/>
+            </a:pPr>
+            <a:r>
+              <a:rPr lang="es-ES" sz="1500" b="1">
                 <a:solidFill>
                   <a:srgbClr val="FFFFFF"/>
                 </a:solidFill>
@@ -3480,7 +3491,7 @@
                 <a:ea typeface="Source Sans Pro" pitchFamily="34" charset="-122"/>
                 <a:cs typeface="Source Sans Pro" pitchFamily="34" charset="-120"/>
               </a:rPr>
-              <a:t>Posicionarse como socio tecnológico</a:t>
+              <a:t>Posicionarse como aliado estratégico en política digital</a:t>
             </a:r>
             <a:endParaRPr lang="en-US" sz="1500" dirty="0"/>
           </a:p>
@@ -3507,11 +3518,11 @@
           <a:bodyPr wrap="square" lIns="0" tIns="0" rIns="0" bIns="0" rtlCol="0" anchor="ctr"/>
           <a:lstStyle/>
           <a:p>
-            <a:pPr indent="0" marL="0">
-              <a:buNone/>
-            </a:pPr>
-            <a:r>
-              <a:rPr lang="en-US" sz="1100" dirty="0">
+            <a:pPr marL="0" indent="0">
+              <a:buNone/>
+            </a:pPr>
+            <a:r>
+              <a:rPr lang="es-ES" sz="1100">
                 <a:solidFill>
                   <a:srgbClr val="A0A0A0"/>
                 </a:solidFill>
@@ -3519,7 +3530,7 @@
                 <a:ea typeface="Source Sans Pro" pitchFamily="34" charset="-122"/>
                 <a:cs typeface="Source Sans Pro" pitchFamily="34" charset="-120"/>
               </a:rPr>
-              <a:t>"Llevamos años construyendo plataformas que digitalizan la relación gobierno-ciudadano" — no como proveedor buscando contrato</a:t>
+              <a:t>"Llevamos años construyendo plataformas que digitalizan la relación gobierno-ciudadano y pueden convertirse en criterios replicables" — no como proveedor buscando contrato</a:t>
             </a:r>
             <a:endParaRPr lang="en-US" sz="1100" dirty="0"/>
           </a:p>
@@ -3566,7 +3577,7 @@
           <a:bodyPr wrap="square" lIns="0" tIns="0" rIns="0" bIns="0" rtlCol="0" anchor="ctr"/>
           <a:lstStyle/>
           <a:p>
-            <a:pPr algn="ctr" indent="0" marL="0">
+            <a:pPr marL="0" indent="0" algn="ctr">
               <a:buNone/>
             </a:pPr>
             <a:r>
@@ -3605,11 +3616,11 @@
           <a:bodyPr wrap="square" lIns="0" tIns="0" rIns="0" bIns="0" rtlCol="0" anchor="ctr"/>
           <a:lstStyle/>
           <a:p>
-            <a:pPr indent="0" marL="0">
-              <a:buNone/>
-            </a:pPr>
-            <a:r>
-              <a:rPr lang="en-US" sz="1500" b="1" dirty="0">
+            <a:pPr marL="0" indent="0">
+              <a:buNone/>
+            </a:pPr>
+            <a:r>
+              <a:rPr lang="es-ES" sz="1500" b="1">
                 <a:solidFill>
                   <a:srgbClr val="FFFFFF"/>
                 </a:solidFill>
@@ -3617,7 +3628,7 @@
                 <a:ea typeface="Source Sans Pro" pitchFamily="34" charset="-122"/>
                 <a:cs typeface="Source Sans Pro" pitchFamily="34" charset="-120"/>
               </a:rPr>
-              <a:t>Hablar en su idioma: datos, IA, escalabilidad</a:t>
+              <a:t>Hablar en su idioma: política pública, estándares, datos, IA y escalabilidad</a:t>
             </a:r>
             <a:endParaRPr lang="en-US" sz="1500" dirty="0"/>
           </a:p>
@@ -3644,11 +3655,11 @@
           <a:bodyPr wrap="square" lIns="0" tIns="0" rIns="0" bIns="0" rtlCol="0" anchor="ctr"/>
           <a:lstStyle/>
           <a:p>
-            <a:pPr indent="0" marL="0">
-              <a:buNone/>
-            </a:pPr>
-            <a:r>
-              <a:rPr lang="en-US" sz="1100" dirty="0">
+            <a:pPr marL="0" indent="0">
+              <a:buNone/>
+            </a:pPr>
+            <a:r>
+              <a:rPr lang="es-ES" sz="1100">
                 <a:solidFill>
                   <a:srgbClr val="A0A0A0"/>
                 </a:solidFill>
@@ -3656,7 +3667,7 @@
                 <a:ea typeface="Source Sans Pro" pitchFamily="34" charset="-122"/>
                 <a:cs typeface="Source Sans Pro" pitchFamily="34" charset="-120"/>
               </a:rPr>
-              <a:t>Él piensa en infraestructura digital federal, no en cuadrillas de reparación. Enfatizar: datos geolocalizados, IA que prioriza, modelo replicable</a:t>
+              <a:t>Él piensa en habilitadores digitales para el país. Enfatizar: datos geolocalizados, IA que prioriza, trazabilidad y modelo replicable</a:t>
             </a:r>
             <a:endParaRPr lang="en-US" sz="1100" dirty="0"/>
           </a:p>
@@ -3703,7 +3714,7 @@
           <a:bodyPr wrap="square" lIns="0" tIns="0" rIns="0" bIns="0" rtlCol="0" anchor="ctr"/>
           <a:lstStyle/>
           <a:p>
-            <a:pPr algn="ctr" indent="0" marL="0">
+            <a:pPr marL="0" indent="0" algn="ctr">
               <a:buNone/>
             </a:pPr>
             <a:r>
@@ -3742,7 +3753,7 @@
           <a:bodyPr wrap="square" lIns="0" tIns="0" rIns="0" bIns="0" rtlCol="0" anchor="ctr"/>
           <a:lstStyle/>
           <a:p>
-            <a:pPr indent="0" marL="0">
+            <a:pPr marL="0" indent="0">
               <a:buNone/>
             </a:pPr>
             <a:r>
@@ -3781,7 +3792,7 @@
           <a:bodyPr wrap="square" lIns="0" tIns="0" rIns="0" bIns="0" rtlCol="0" anchor="ctr"/>
           <a:lstStyle/>
           <a:p>
-            <a:pPr indent="0" marL="0">
+            <a:pPr marL="0" indent="0">
               <a:buNone/>
             </a:pPr>
             <a:r>
@@ -3840,7 +3851,7 @@
           <a:bodyPr wrap="square" lIns="0" tIns="0" rIns="0" bIns="0" rtlCol="0" anchor="ctr"/>
           <a:lstStyle/>
           <a:p>
-            <a:pPr algn="ctr" indent="0" marL="0">
+            <a:pPr marL="0" indent="0" algn="ctr">
               <a:buNone/>
             </a:pPr>
             <a:r>
@@ -3879,7 +3890,7 @@
           <a:bodyPr wrap="square" lIns="0" tIns="0" rIns="0" bIns="0" rtlCol="0" anchor="ctr"/>
           <a:lstStyle/>
           <a:p>
-            <a:pPr indent="0" marL="0">
+            <a:pPr marL="0" indent="0">
               <a:buNone/>
             </a:pPr>
             <a:r>
@@ -3918,11 +3929,11 @@
           <a:bodyPr wrap="square" lIns="0" tIns="0" rIns="0" bIns="0" rtlCol="0" anchor="ctr"/>
           <a:lstStyle/>
           <a:p>
-            <a:pPr indent="0" marL="0">
-              <a:buNone/>
-            </a:pPr>
-            <a:r>
-              <a:rPr lang="en-US" sz="1100" dirty="0">
+            <a:pPr marL="0" indent="0">
+              <a:buNone/>
+            </a:pPr>
+            <a:r>
+              <a:rPr lang="es-ES" sz="1100">
                 <a:solidFill>
                   <a:srgbClr val="A0A0A0"/>
                 </a:solidFill>
@@ -3930,7 +3941,7 @@
                 <a:ea typeface="Source Sans Pro" pitchFamily="34" charset="-122"/>
                 <a:cs typeface="Source Sans Pro" pitchFamily="34" charset="-120"/>
               </a:rPr>
-              <a:t>"¿Existe la visión de un estándar nacional de gestión de servicios urbanos digitales?" — esto lo posiciona como aliado de su agenda</a:t>
+              <a:t>"¿Existe la visión de un estándar nacional de gestión de servicios urbanos digitales?" — esto lo posiciona dentro de política pública digital y adopción nacional</a:t>
             </a:r>
             <a:endParaRPr lang="en-US" sz="1100" dirty="0"/>
           </a:p>
@@ -3952,6 +3963,7 @@
         <a:solidFill>
           <a:srgbClr val="1B1A1B"/>
         </a:solidFill>
+        <a:effectLst/>
       </p:bgPr>
     </p:bg>
     <p:spTree>
@@ -3989,11 +4001,11 @@
           <a:bodyPr wrap="square" lIns="0" tIns="0" rIns="0" bIns="0" rtlCol="0" anchor="ctr"/>
           <a:lstStyle/>
           <a:p>
-            <a:pPr indent="0" marL="0">
-              <a:buNone/>
-            </a:pPr>
-            <a:r>
-              <a:rPr lang="en-US" sz="1000" b="1" spc="400" kern="0" dirty="0">
+            <a:pPr marL="0" indent="0">
+              <a:buNone/>
+            </a:pPr>
+            <a:r>
+              <a:rPr lang="en-US" sz="1000" b="1" kern="0" spc="400" dirty="0">
                 <a:solidFill>
                   <a:srgbClr val="E53935"/>
                 </a:solidFill>
@@ -4028,7 +4040,7 @@
           <a:bodyPr wrap="square" lIns="0" tIns="0" rIns="0" bIns="0" rtlCol="0" anchor="ctr"/>
           <a:lstStyle/>
           <a:p>
-            <a:pPr indent="0" marL="0">
+            <a:pPr marL="0" indent="0">
               <a:buNone/>
             </a:pPr>
             <a:r>
@@ -4087,7 +4099,7 @@
           <a:bodyPr wrap="square" lIns="0" tIns="0" rIns="0" bIns="0" rtlCol="0" anchor="ctr"/>
           <a:lstStyle/>
           <a:p>
-            <a:pPr algn="ctr" indent="0" marL="0">
+            <a:pPr marL="0" indent="0" algn="ctr">
               <a:buNone/>
             </a:pPr>
             <a:r>
@@ -4126,7 +4138,7 @@
           <a:bodyPr wrap="square" lIns="0" tIns="0" rIns="0" bIns="0" rtlCol="0" anchor="ctr"/>
           <a:lstStyle/>
           <a:p>
-            <a:pPr indent="0" marL="0">
+            <a:pPr marL="0" indent="0">
               <a:buNone/>
             </a:pPr>
             <a:r>
@@ -4165,7 +4177,7 @@
           <a:bodyPr wrap="square" lIns="0" tIns="0" rIns="0" bIns="0" rtlCol="0" anchor="ctr"/>
           <a:lstStyle/>
           <a:p>
-            <a:pPr indent="0" marL="0">
+            <a:pPr marL="0" indent="0">
               <a:buNone/>
             </a:pPr>
             <a:r>
@@ -4224,7 +4236,7 @@
           <a:bodyPr wrap="square" lIns="0" tIns="0" rIns="0" bIns="0" rtlCol="0" anchor="ctr"/>
           <a:lstStyle/>
           <a:p>
-            <a:pPr algn="ctr" indent="0" marL="0">
+            <a:pPr marL="0" indent="0" algn="ctr">
               <a:buNone/>
             </a:pPr>
             <a:r>
@@ -4263,7 +4275,7 @@
           <a:bodyPr wrap="square" lIns="0" tIns="0" rIns="0" bIns="0" rtlCol="0" anchor="ctr"/>
           <a:lstStyle/>
           <a:p>
-            <a:pPr indent="0" marL="0">
+            <a:pPr marL="0" indent="0">
               <a:buNone/>
             </a:pPr>
             <a:r>
@@ -4302,11 +4314,11 @@
           <a:bodyPr wrap="square" lIns="0" tIns="0" rIns="0" bIns="0" rtlCol="0" anchor="ctr"/>
           <a:lstStyle/>
           <a:p>
-            <a:pPr indent="0" marL="0">
-              <a:buNone/>
-            </a:pPr>
-            <a:r>
-              <a:rPr lang="en-US" sz="1100" dirty="0">
+            <a:pPr marL="0" indent="0">
+              <a:buNone/>
+            </a:pPr>
+            <a:r>
+              <a:rPr lang="es-ES" sz="1100">
                 <a:solidFill>
                   <a:srgbClr val="A0A0A0"/>
                 </a:solidFill>
@@ -4314,7 +4326,7 @@
                 <a:ea typeface="Source Sans Pro" pitchFamily="34" charset="-122"/>
                 <a:cs typeface="Source Sans Pro" pitchFamily="34" charset="-120"/>
               </a:rPr>
-              <a:t>La presentación está diseñada para presidentes municipales ("¡piloto en su municipio!"). Él es nivel federal. Usar solo las 3-4 pantallas de la plataforma como referencia visual, sin recorrer las 23 slides.</a:t>
+              <a:t>La presentación está diseñada para presidentes municipales ("¡piloto en su municipio!"). Él es nivel federal. Usar sólo pantallas seleccionadas como referencia visual, sin recorrer la presentación completa.</a:t>
             </a:r>
             <a:endParaRPr lang="en-US" sz="1100" dirty="0"/>
           </a:p>
@@ -4361,7 +4373,7 @@
           <a:bodyPr wrap="square" lIns="0" tIns="0" rIns="0" bIns="0" rtlCol="0" anchor="ctr"/>
           <a:lstStyle/>
           <a:p>
-            <a:pPr algn="ctr" indent="0" marL="0">
+            <a:pPr marL="0" indent="0" algn="ctr">
               <a:buNone/>
             </a:pPr>
             <a:r>
@@ -4400,11 +4412,11 @@
           <a:bodyPr wrap="square" lIns="0" tIns="0" rIns="0" bIns="0" rtlCol="0" anchor="ctr"/>
           <a:lstStyle/>
           <a:p>
-            <a:pPr indent="0" marL="0">
-              <a:buNone/>
-            </a:pPr>
-            <a:r>
-              <a:rPr lang="en-US" sz="1500" b="1" dirty="0">
+            <a:pPr marL="0" indent="0">
+              <a:buNone/>
+            </a:pPr>
+            <a:r>
+              <a:rPr lang="es-ES" sz="1500" b="1">
                 <a:solidFill>
                   <a:srgbClr val="FFFFFF"/>
                 </a:solidFill>
@@ -4412,7 +4424,7 @@
                 <a:ea typeface="Source Sans Pro" pitchFamily="34" charset="-122"/>
                 <a:cs typeface="Source Sans Pro" pitchFamily="34" charset="-120"/>
               </a:rPr>
-              <a:t>No hablar de "tapar baches" o servicios urbanos operativos</a:t>
+              <a:t>No bajar la conversación a ejecución operativa o implementación aislada</a:t>
             </a:r>
             <a:endParaRPr lang="en-US" sz="1500" dirty="0"/>
           </a:p>
@@ -4439,11 +4451,11 @@
           <a:bodyPr wrap="square" lIns="0" tIns="0" rIns="0" bIns="0" rtlCol="0" anchor="ctr"/>
           <a:lstStyle/>
           <a:p>
-            <a:pPr indent="0" marL="0">
-              <a:buNone/>
-            </a:pPr>
-            <a:r>
-              <a:rPr lang="en-US" sz="1100" dirty="0">
+            <a:pPr marL="0" indent="0">
+              <a:buNone/>
+            </a:pPr>
+            <a:r>
+              <a:rPr lang="es-ES" sz="1100">
                 <a:solidFill>
                   <a:srgbClr val="A0A0A0"/>
                 </a:solidFill>
@@ -4451,7 +4463,7 @@
                 <a:ea typeface="Source Sans Pro" pitchFamily="34" charset="-122"/>
                 <a:cs typeface="Source Sans Pro" pitchFamily="34" charset="-120"/>
               </a:rPr>
-              <a:t>Su carrera es digital: Llave CDMX, plataformas ciudadanas, gobierno abierto. No es el funcionario que coordina cuadrillas. Hablar de la plataforma como infraestructura digital, no como herramienta de campo.</a:t>
+              <a:t>Su carrera es digital: Llave CDMX, plataformas ciudadanas, gobierno abierto. El valor está en cómo una solución puede convertirse en estándar, política, lineamiento o referencia nacional para gobiernos locales.</a:t>
             </a:r>
             <a:endParaRPr lang="en-US" sz="1100" dirty="0"/>
           </a:p>
@@ -4498,7 +4510,7 @@
           <a:bodyPr wrap="square" lIns="0" tIns="0" rIns="0" bIns="0" rtlCol="0" anchor="ctr"/>
           <a:lstStyle/>
           <a:p>
-            <a:pPr algn="ctr" indent="0" marL="0">
+            <a:pPr marL="0" indent="0" algn="ctr">
               <a:buNone/>
             </a:pPr>
             <a:r>
@@ -4537,11 +4549,11 @@
           <a:bodyPr wrap="square" lIns="0" tIns="0" rIns="0" bIns="0" rtlCol="0" anchor="ctr"/>
           <a:lstStyle/>
           <a:p>
-            <a:pPr indent="0" marL="0">
-              <a:buNone/>
-            </a:pPr>
-            <a:r>
-              <a:rPr lang="en-US" sz="1500" b="1" dirty="0">
+            <a:pPr marL="0" indent="0">
+              <a:buNone/>
+            </a:pPr>
+            <a:r>
+              <a:rPr lang="es-ES" sz="1500" b="1">
                 <a:solidFill>
                   <a:srgbClr val="FFFFFF"/>
                 </a:solidFill>
@@ -4549,7 +4561,7 @@
                 <a:ea typeface="Source Sans Pro" pitchFamily="34" charset="-122"/>
                 <a:cs typeface="Source Sans Pro" pitchFamily="34" charset="-120"/>
               </a:rPr>
-              <a:t>No pedir una reunión con "el área de obras"</a:t>
+              <a:t>No pedir una reunión con "obras" ni con un área puramente operativa</a:t>
             </a:r>
             <a:endParaRPr lang="en-US" sz="1500" dirty="0"/>
           </a:p>
@@ -4576,11 +4588,11 @@
           <a:bodyPr wrap="square" lIns="0" tIns="0" rIns="0" bIns="0" rtlCol="0" anchor="ctr"/>
           <a:lstStyle/>
           <a:p>
-            <a:pPr indent="0" marL="0">
-              <a:buNone/>
-            </a:pPr>
-            <a:r>
-              <a:rPr lang="en-US" sz="1100" dirty="0">
+            <a:pPr marL="0" indent="0">
+              <a:buNone/>
+            </a:pPr>
+            <a:r>
+              <a:rPr lang="es-ES" sz="1100">
                 <a:solidFill>
                   <a:srgbClr val="A0A0A0"/>
                 </a:solidFill>
@@ -4588,7 +4600,7 @@
                 <a:ea typeface="Source Sans Pro" pitchFamily="34" charset="-122"/>
                 <a:cs typeface="Source Sans Pro" pitchFamily="34" charset="-120"/>
               </a:rPr>
-              <a:t>El cierre correcto es pedir que nos conecte con el área de la ATDT que define estándares tecnológicos para municipios, no con operaciones urbanas.</a:t>
+              <a:t>El cierre correcto es pedir que nos conecte con el área de la ATDT que define criterios, estándares tecnológicos y modelos de adopción para municipios.</a:t>
             </a:r>
             <a:endParaRPr lang="en-US" sz="1100" dirty="0"/>
           </a:p>
@@ -4610,6 +4622,7 @@
         <a:solidFill>
           <a:srgbClr val="1B1A1B"/>
         </a:solidFill>
+        <a:effectLst/>
       </p:bgPr>
     </p:bg>
     <p:spTree>
@@ -4647,11 +4660,11 @@
           <a:bodyPr wrap="square" lIns="0" tIns="0" rIns="0" bIns="0" rtlCol="0" anchor="ctr"/>
           <a:lstStyle/>
           <a:p>
-            <a:pPr indent="0" marL="0">
-              <a:buNone/>
-            </a:pPr>
-            <a:r>
-              <a:rPr lang="en-US" sz="1000" b="1" spc="400" kern="0" dirty="0">
+            <a:pPr marL="0" indent="0">
+              <a:buNone/>
+            </a:pPr>
+            <a:r>
+              <a:rPr lang="en-US" sz="1000" b="1" kern="0" spc="400" dirty="0">
                 <a:solidFill>
                   <a:srgbClr val="A0A0A0"/>
                 </a:solidFill>
@@ -4686,7 +4699,7 @@
           <a:bodyPr wrap="square" lIns="0" tIns="0" rIns="0" bIns="0" rtlCol="0" anchor="ctr"/>
           <a:lstStyle/>
           <a:p>
-            <a:pPr indent="0" marL="0">
+            <a:pPr marL="0" indent="0">
               <a:buNone/>
             </a:pPr>
             <a:r>
@@ -4723,7 +4736,7 @@
           </a:solidFill>
           <a:ln/>
           <a:effectLst>
-            <a:outerShdw sx="100000" sy="100000" kx="0" ky="0" algn="bl" rotWithShape="0" blurRad="101600" dist="38100" dir="8100000">
+            <a:outerShdw blurRad="101600" dist="38100" dir="8100000" algn="bl" rotWithShape="0">
               <a:srgbClr val="000000">
                 <a:alpha val="30000"/>
               </a:srgbClr>
@@ -4772,11 +4785,11 @@
           <a:bodyPr wrap="square" lIns="0" tIns="0" rIns="0" bIns="0" rtlCol="0" anchor="ctr"/>
           <a:lstStyle/>
           <a:p>
-            <a:pPr indent="0" marL="0">
-              <a:buNone/>
-            </a:pPr>
-            <a:r>
-              <a:rPr lang="en-US" sz="900" b="1" spc="300" kern="0" dirty="0">
+            <a:pPr marL="0" indent="0">
+              <a:buNone/>
+            </a:pPr>
+            <a:r>
+              <a:rPr lang="en-US" sz="900" b="1" kern="0" spc="300" dirty="0">
                 <a:solidFill>
                   <a:srgbClr val="4CAF50"/>
                 </a:solidFill>
@@ -4811,14 +4824,14 @@
           <a:bodyPr wrap="square" lIns="0" tIns="0" rIns="0" bIns="0" rtlCol="0" anchor="ctr"/>
           <a:lstStyle/>
           <a:p>
-            <a:pPr indent="0" marL="0">
+            <a:pPr marL="0" indent="0">
               <a:spcAft>
                 <a:spcPts val="200"/>
               </a:spcAft>
               <a:buNone/>
             </a:pPr>
             <a:r>
-              <a:rPr lang="en-US" sz="1100" b="1" dirty="0">
+              <a:rPr lang="es-ES" sz="1100" b="1">
                 <a:solidFill>
                   <a:srgbClr val="FFFFFF"/>
                 </a:solidFill>
@@ -4828,19 +4841,18 @@
               </a:rPr>
               <a:t>Slide 4 — Sistema Automatizado</a:t>
             </a:r>
-            <a:endParaRPr lang="en-US" sz="1100" dirty="0"/>
-          </a:p>
-          <a:p>
-            <a:pPr indent="0" marL="0">
+          </a:p>
+          <a:p>
+            <a:pPr marL="0" indent="0">
               <a:spcAft>
                 <a:spcPts val="200"/>
               </a:spcAft>
               <a:buNone/>
             </a:pPr>
             <a:r>
-              <a:rPr lang="en-US" sz="1000" dirty="0">
-                <a:solidFill>
-                  <a:srgbClr val="A0A0A0"/>
+              <a:rPr lang="es-ES" sz="1100" b="1">
+                <a:solidFill>
+                  <a:srgbClr val="FFFFFF"/>
                 </a:solidFill>
                 <a:latin typeface="Source Sans Pro" pitchFamily="34" charset="0"/>
                 <a:ea typeface="Source Sans Pro" pitchFamily="34" charset="-122"/>
@@ -4848,26 +4860,32 @@
               </a:rPr>
               <a:t>IA + participación + evidencia geolocalizada. Traduce al lenguaje de infraestructura digital.</a:t>
             </a:r>
-            <a:endParaRPr lang="en-US" sz="1100" dirty="0"/>
-          </a:p>
-          <a:p>
-            <a:pPr indent="0" marL="0">
+          </a:p>
+          <a:p>
+            <a:pPr marL="0" indent="0">
               <a:spcAft>
                 <a:spcPts val="200"/>
               </a:spcAft>
               <a:buNone/>
             </a:pPr>
-            <a:endParaRPr lang="en-US" sz="1100" dirty="0"/>
-          </a:p>
-          <a:p>
-            <a:pPr indent="0" marL="0">
+            <a:endParaRPr lang="es-ES" sz="1100" b="1">
+              <a:solidFill>
+                <a:srgbClr val="FFFFFF"/>
+              </a:solidFill>
+              <a:latin typeface="Source Sans Pro" pitchFamily="34" charset="0"/>
+              <a:ea typeface="Source Sans Pro" pitchFamily="34" charset="-122"/>
+              <a:cs typeface="Source Sans Pro" pitchFamily="34" charset="-120"/>
+            </a:endParaRPr>
+          </a:p>
+          <a:p>
+            <a:pPr marL="0" indent="0">
               <a:spcAft>
                 <a:spcPts val="200"/>
               </a:spcAft>
               <a:buNone/>
             </a:pPr>
             <a:r>
-              <a:rPr lang="en-US" sz="1100" b="1" dirty="0">
+              <a:rPr lang="es-ES" sz="1100" b="1">
                 <a:solidFill>
                   <a:srgbClr val="FFFFFF"/>
                 </a:solidFill>
@@ -4877,19 +4895,18 @@
               </a:rPr>
               <a:t>Slide 7 — El Sistema en 3 Pasos</a:t>
             </a:r>
-            <a:endParaRPr lang="en-US" sz="1100" dirty="0"/>
-          </a:p>
-          <a:p>
-            <a:pPr indent="0" marL="0">
+          </a:p>
+          <a:p>
+            <a:pPr marL="0" indent="0">
               <a:spcAft>
                 <a:spcPts val="200"/>
               </a:spcAft>
               <a:buNone/>
             </a:pPr>
             <a:r>
-              <a:rPr lang="en-US" sz="1000" dirty="0">
-                <a:solidFill>
-                  <a:srgbClr val="A0A0A0"/>
+              <a:rPr lang="es-ES" sz="1100" b="1">
+                <a:solidFill>
+                  <a:srgbClr val="FFFFFF"/>
                 </a:solidFill>
                 <a:latin typeface="Source Sans Pro" pitchFamily="34" charset="0"/>
                 <a:ea typeface="Source Sans Pro" pitchFamily="34" charset="-122"/>
@@ -4897,26 +4914,32 @@
               </a:rPr>
               <a:t>Flujo completo sin detalle operativo. Claro y ejecutivo.</a:t>
             </a:r>
-            <a:endParaRPr lang="en-US" sz="1100" dirty="0"/>
-          </a:p>
-          <a:p>
-            <a:pPr indent="0" marL="0">
+          </a:p>
+          <a:p>
+            <a:pPr marL="0" indent="0">
               <a:spcAft>
                 <a:spcPts val="200"/>
               </a:spcAft>
               <a:buNone/>
             </a:pPr>
-            <a:endParaRPr lang="en-US" sz="1100" dirty="0"/>
-          </a:p>
-          <a:p>
-            <a:pPr indent="0" marL="0">
+            <a:endParaRPr lang="es-ES" sz="1100" b="1">
+              <a:solidFill>
+                <a:srgbClr val="FFFFFF"/>
+              </a:solidFill>
+              <a:latin typeface="Source Sans Pro" pitchFamily="34" charset="0"/>
+              <a:ea typeface="Source Sans Pro" pitchFamily="34" charset="-122"/>
+              <a:cs typeface="Source Sans Pro" pitchFamily="34" charset="-120"/>
+            </a:endParaRPr>
+          </a:p>
+          <a:p>
+            <a:pPr marL="0" indent="0">
               <a:spcAft>
                 <a:spcPts val="200"/>
               </a:spcAft>
               <a:buNone/>
             </a:pPr>
             <a:r>
-              <a:rPr lang="en-US" sz="1100" b="1" dirty="0">
+              <a:rPr lang="es-ES" sz="1100" b="1">
                 <a:solidFill>
                   <a:srgbClr val="FFFFFF"/>
                 </a:solidFill>
@@ -4926,46 +4949,51 @@
               </a:rPr>
               <a:t>Slide 12 — Por Qué Funciona</a:t>
             </a:r>
-            <a:endParaRPr lang="en-US" sz="1100" dirty="0"/>
-          </a:p>
-          <a:p>
-            <a:pPr indent="0" marL="0">
+          </a:p>
+          <a:p>
+            <a:pPr marL="0" indent="0">
               <a:spcAft>
                 <a:spcPts val="200"/>
               </a:spcAft>
               <a:buNone/>
             </a:pPr>
             <a:r>
-              <a:rPr lang="en-US" sz="1000" dirty="0">
-                <a:solidFill>
-                  <a:srgbClr val="A0A0A0"/>
+              <a:rPr lang="es-ES" sz="1100" b="1">
+                <a:solidFill>
+                  <a:srgbClr val="FFFFFF"/>
                 </a:solidFill>
                 <a:latin typeface="Source Sans Pro" pitchFamily="34" charset="0"/>
                 <a:ea typeface="Source Sans Pro" pitchFamily="34" charset="-122"/>
                 <a:cs typeface="Source Sans Pro" pitchFamily="34" charset="-120"/>
               </a:rPr>
-              <a:t>Evidencia, IA, dashboard, costos. Los 4 pilares que conectan con transparencia.</a:t>
-            </a:r>
-            <a:endParaRPr lang="en-US" sz="1100" dirty="0"/>
-          </a:p>
-          <a:p>
-            <a:pPr indent="0" marL="0">
+              <a:t>Evidencia, IA, dashboard, costos. Los 4 pilares que conectan con transparencia y rendición de cuentas.</a:t>
+            </a:r>
+          </a:p>
+          <a:p>
+            <a:pPr marL="0" indent="0">
               <a:spcAft>
                 <a:spcPts val="200"/>
               </a:spcAft>
               <a:buNone/>
             </a:pPr>
-            <a:endParaRPr lang="en-US" sz="1100" dirty="0"/>
-          </a:p>
-          <a:p>
-            <a:pPr indent="0" marL="0">
+            <a:endParaRPr lang="es-ES" sz="1100" b="1">
+              <a:solidFill>
+                <a:srgbClr val="FFFFFF"/>
+              </a:solidFill>
+              <a:latin typeface="Source Sans Pro" pitchFamily="34" charset="0"/>
+              <a:ea typeface="Source Sans Pro" pitchFamily="34" charset="-122"/>
+              <a:cs typeface="Source Sans Pro" pitchFamily="34" charset="-120"/>
+            </a:endParaRPr>
+          </a:p>
+          <a:p>
+            <a:pPr marL="0" indent="0">
               <a:spcAft>
                 <a:spcPts val="200"/>
               </a:spcAft>
               <a:buNone/>
             </a:pPr>
             <a:r>
-              <a:rPr lang="en-US" sz="1100" b="1" dirty="0">
+              <a:rPr lang="es-ES" sz="1100" b="1">
                 <a:solidFill>
                   <a:srgbClr val="FFFFFF"/>
                 </a:solidFill>
@@ -4973,27 +5001,26 @@
                 <a:ea typeface="Source Sans Pro" pitchFamily="34" charset="-122"/>
                 <a:cs typeface="Source Sans Pro" pitchFamily="34" charset="-120"/>
               </a:rPr>
-              <a:t>Slide 20 — Dashboard Ejecutivo</a:t>
-            </a:r>
-            <a:endParaRPr lang="en-US" sz="1100" dirty="0"/>
-          </a:p>
-          <a:p>
-            <a:pPr indent="0" marL="0">
+              <a:t>Slides 13–14 — Cierre visual</a:t>
+            </a:r>
+          </a:p>
+          <a:p>
+            <a:pPr marL="0" indent="0">
               <a:spcAft>
                 <a:spcPts val="200"/>
               </a:spcAft>
               <a:buNone/>
             </a:pPr>
             <a:r>
-              <a:rPr lang="en-US" sz="1000" dirty="0">
-                <a:solidFill>
-                  <a:srgbClr val="A0A0A0"/>
+              <a:rPr lang="es-ES" sz="1100" b="1">
+                <a:solidFill>
+                  <a:srgbClr val="FFFFFF"/>
                 </a:solidFill>
                 <a:latin typeface="Source Sans Pro" pitchFamily="34" charset="0"/>
                 <a:ea typeface="Source Sans Pro" pitchFamily="34" charset="-122"/>
                 <a:cs typeface="Source Sans Pro" pitchFamily="34" charset="-120"/>
               </a:rPr>
-              <a:t>KPIs, presupuesto, productividad. Habla a su perfil de toma de decisiones.</a:t>
+              <a:t>Piloto y portal ciudadano. Útiles sólo si la conversación baja a implementación; no abrir con esto.</a:t>
             </a:r>
             <a:endParaRPr lang="en-US" sz="1100" dirty="0"/>
           </a:p>
@@ -5018,7 +5045,7 @@
           </a:solidFill>
           <a:ln/>
           <a:effectLst>
-            <a:outerShdw sx="100000" sy="100000" kx="0" ky="0" algn="bl" rotWithShape="0" blurRad="101600" dist="38100" dir="8100000">
+            <a:outerShdw blurRad="101600" dist="38100" dir="8100000" algn="bl" rotWithShape="0">
               <a:srgbClr val="000000">
                 <a:alpha val="30000"/>
               </a:srgbClr>
@@ -5067,11 +5094,11 @@
           <a:bodyPr wrap="square" lIns="0" tIns="0" rIns="0" bIns="0" rtlCol="0" anchor="ctr"/>
           <a:lstStyle/>
           <a:p>
-            <a:pPr indent="0" marL="0">
-              <a:buNone/>
-            </a:pPr>
-            <a:r>
-              <a:rPr lang="en-US" sz="900" b="1" spc="300" kern="0" dirty="0">
+            <a:pPr marL="0" indent="0">
+              <a:buNone/>
+            </a:pPr>
+            <a:r>
+              <a:rPr lang="en-US" sz="900" b="1" kern="0" spc="300" dirty="0">
                 <a:solidFill>
                   <a:srgbClr val="E53935"/>
                 </a:solidFill>
@@ -5079,7 +5106,7 @@
                 <a:ea typeface="Calibri" pitchFamily="34" charset="-122"/>
                 <a:cs typeface="Calibri" pitchFamily="34" charset="-120"/>
               </a:rPr>
-              <a:t>NO USAR</a:t>
+              <a:t>NO USAR COMO EJE</a:t>
             </a:r>
             <a:endParaRPr lang="en-US" sz="900" dirty="0"/>
           </a:p>
@@ -5106,14 +5133,14 @@
           <a:bodyPr wrap="square" lIns="0" tIns="0" rIns="0" bIns="0" rtlCol="0" anchor="ctr"/>
           <a:lstStyle/>
           <a:p>
-            <a:pPr indent="0" marL="0">
+            <a:pPr marL="0" indent="0">
               <a:spcAft>
                 <a:spcPts val="200"/>
               </a:spcAft>
               <a:buNone/>
             </a:pPr>
             <a:r>
-              <a:rPr lang="en-US" sz="1100" b="1" dirty="0">
+              <a:rPr lang="es-ES" sz="1100" b="1">
                 <a:solidFill>
                   <a:srgbClr val="FFFFFF"/>
                 </a:solidFill>
@@ -5123,19 +5150,18 @@
               </a:rPr>
               <a:t>Slides 1-3 — Problemática</a:t>
             </a:r>
-            <a:endParaRPr lang="en-US" sz="1100" dirty="0"/>
-          </a:p>
-          <a:p>
-            <a:pPr indent="0" marL="0">
+          </a:p>
+          <a:p>
+            <a:pPr marL="0" indent="0">
               <a:spcAft>
                 <a:spcPts val="200"/>
               </a:spcAft>
               <a:buNone/>
             </a:pPr>
             <a:r>
-              <a:rPr lang="en-US" sz="1000" dirty="0">
-                <a:solidFill>
-                  <a:srgbClr val="A0A0A0"/>
+              <a:rPr lang="es-ES" sz="1100" b="1">
+                <a:solidFill>
+                  <a:srgbClr val="FFFFFF"/>
                 </a:solidFill>
                 <a:latin typeface="Source Sans Pro" pitchFamily="34" charset="0"/>
                 <a:ea typeface="Source Sans Pro" pitchFamily="34" charset="-122"/>
@@ -5143,26 +5169,32 @@
               </a:rPr>
               <a:t>Él ya conoce el problema. No necesita la explicación.</a:t>
             </a:r>
-            <a:endParaRPr lang="en-US" sz="1100" dirty="0"/>
-          </a:p>
-          <a:p>
-            <a:pPr indent="0" marL="0">
+          </a:p>
+          <a:p>
+            <a:pPr marL="0" indent="0">
               <a:spcAft>
                 <a:spcPts val="200"/>
               </a:spcAft>
               <a:buNone/>
             </a:pPr>
-            <a:endParaRPr lang="en-US" sz="1100" dirty="0"/>
-          </a:p>
-          <a:p>
-            <a:pPr indent="0" marL="0">
+            <a:endParaRPr lang="es-ES" sz="1100" b="1">
+              <a:solidFill>
+                <a:srgbClr val="FFFFFF"/>
+              </a:solidFill>
+              <a:latin typeface="Source Sans Pro" pitchFamily="34" charset="0"/>
+              <a:ea typeface="Source Sans Pro" pitchFamily="34" charset="-122"/>
+              <a:cs typeface="Source Sans Pro" pitchFamily="34" charset="-120"/>
+            </a:endParaRPr>
+          </a:p>
+          <a:p>
+            <a:pPr marL="0" indent="0">
               <a:spcAft>
                 <a:spcPts val="200"/>
               </a:spcAft>
               <a:buNone/>
             </a:pPr>
             <a:r>
-              <a:rPr lang="en-US" sz="1100" b="1" dirty="0">
+              <a:rPr lang="es-ES" sz="1100" b="1">
                 <a:solidFill>
                   <a:srgbClr val="FFFFFF"/>
                 </a:solidFill>
@@ -5172,19 +5204,18 @@
               </a:rPr>
               <a:t>Slides 6, 8, 9 — Detalle operativo</a:t>
             </a:r>
-            <a:endParaRPr lang="en-US" sz="1100" dirty="0"/>
-          </a:p>
-          <a:p>
-            <a:pPr indent="0" marL="0">
+          </a:p>
+          <a:p>
+            <a:pPr marL="0" indent="0">
               <a:spcAft>
                 <a:spcPts val="200"/>
               </a:spcAft>
               <a:buNone/>
             </a:pPr>
             <a:r>
-              <a:rPr lang="en-US" sz="1000" dirty="0">
-                <a:solidFill>
-                  <a:srgbClr val="A0A0A0"/>
+              <a:rPr lang="es-ES" sz="1100" b="1">
+                <a:solidFill>
+                  <a:srgbClr val="FFFFFF"/>
                 </a:solidFill>
                 <a:latin typeface="Source Sans Pro" pitchFamily="34" charset="0"/>
                 <a:ea typeface="Source Sans Pro" pitchFamily="34" charset="-122"/>
@@ -5192,26 +5223,32 @@
               </a:rPr>
               <a:t>App del censador, 8 servicios. Demasiado granular para nivel federal. Solo si pregunta.</a:t>
             </a:r>
-            <a:endParaRPr lang="en-US" sz="1100" dirty="0"/>
-          </a:p>
-          <a:p>
-            <a:pPr indent="0" marL="0">
+          </a:p>
+          <a:p>
+            <a:pPr marL="0" indent="0">
               <a:spcAft>
                 <a:spcPts val="200"/>
               </a:spcAft>
               <a:buNone/>
             </a:pPr>
-            <a:endParaRPr lang="en-US" sz="1100" dirty="0"/>
-          </a:p>
-          <a:p>
-            <a:pPr indent="0" marL="0">
+            <a:endParaRPr lang="es-ES" sz="1100" b="1">
+              <a:solidFill>
+                <a:srgbClr val="FFFFFF"/>
+              </a:solidFill>
+              <a:latin typeface="Source Sans Pro" pitchFamily="34" charset="0"/>
+              <a:ea typeface="Source Sans Pro" pitchFamily="34" charset="-122"/>
+              <a:cs typeface="Source Sans Pro" pitchFamily="34" charset="-120"/>
+            </a:endParaRPr>
+          </a:p>
+          <a:p>
+            <a:pPr marL="0" indent="0">
               <a:spcAft>
                 <a:spcPts val="200"/>
               </a:spcAft>
               <a:buNone/>
             </a:pPr>
             <a:r>
-              <a:rPr lang="en-US" sz="1100" b="1" dirty="0">
+              <a:rPr lang="es-ES" sz="1100" b="1">
                 <a:solidFill>
                   <a:srgbClr val="FFFFFF"/>
                 </a:solidFill>
@@ -5221,19 +5258,18 @@
               </a:rPr>
               <a:t>Slide 10 — Caso Bache 24</a:t>
             </a:r>
-            <a:endParaRPr lang="en-US" sz="1100" dirty="0"/>
-          </a:p>
-          <a:p>
-            <a:pPr indent="0" marL="0">
+          </a:p>
+          <a:p>
+            <a:pPr marL="0" indent="0">
               <a:spcAft>
                 <a:spcPts val="200"/>
               </a:spcAft>
               <a:buNone/>
             </a:pPr>
             <a:r>
-              <a:rPr lang="en-US" sz="1000" dirty="0">
-                <a:solidFill>
-                  <a:srgbClr val="A0A0A0"/>
+              <a:rPr lang="es-ES" sz="1100" b="1">
+                <a:solidFill>
+                  <a:srgbClr val="FFFFFF"/>
                 </a:solidFill>
                 <a:latin typeface="Source Sans Pro" pitchFamily="34" charset="0"/>
                 <a:ea typeface="Source Sans Pro" pitchFamily="34" charset="-122"/>
@@ -5241,26 +5277,32 @@
               </a:rPr>
               <a:t>Era Mancera, posible carga política. No liderar con esto. Solo si él pregunta.</a:t>
             </a:r>
-            <a:endParaRPr lang="en-US" sz="1100" dirty="0"/>
-          </a:p>
-          <a:p>
-            <a:pPr indent="0" marL="0">
+          </a:p>
+          <a:p>
+            <a:pPr marL="0" indent="0">
               <a:spcAft>
                 <a:spcPts val="200"/>
               </a:spcAft>
               <a:buNone/>
             </a:pPr>
-            <a:endParaRPr lang="en-US" sz="1100" dirty="0"/>
-          </a:p>
-          <a:p>
-            <a:pPr indent="0" marL="0">
+            <a:endParaRPr lang="es-ES" sz="1100" b="1">
+              <a:solidFill>
+                <a:srgbClr val="FFFFFF"/>
+              </a:solidFill>
+              <a:latin typeface="Source Sans Pro" pitchFamily="34" charset="0"/>
+              <a:ea typeface="Source Sans Pro" pitchFamily="34" charset="-122"/>
+              <a:cs typeface="Source Sans Pro" pitchFamily="34" charset="-120"/>
+            </a:endParaRPr>
+          </a:p>
+          <a:p>
+            <a:pPr marL="0" indent="0">
               <a:spcAft>
                 <a:spcPts val="200"/>
               </a:spcAft>
               <a:buNone/>
             </a:pPr>
             <a:r>
-              <a:rPr lang="en-US" sz="1100" b="1" dirty="0">
+              <a:rPr lang="es-ES" sz="1100" b="1">
                 <a:solidFill>
                   <a:srgbClr val="FFFFFF"/>
                 </a:solidFill>
@@ -5270,25 +5312,24 @@
               </a:rPr>
               <a:t>Slide 13 — CTA municipal</a:t>
             </a:r>
-            <a:endParaRPr lang="en-US" sz="1100" dirty="0"/>
-          </a:p>
-          <a:p>
-            <a:pPr indent="0" marL="0">
+          </a:p>
+          <a:p>
+            <a:pPr marL="0" indent="0">
               <a:spcAft>
                 <a:spcPts val="200"/>
               </a:spcAft>
               <a:buNone/>
             </a:pPr>
             <a:r>
-              <a:rPr lang="en-US" sz="1000" dirty="0">
-                <a:solidFill>
-                  <a:srgbClr val="A0A0A0"/>
+              <a:rPr lang="es-ES" sz="1100" b="1">
+                <a:solidFill>
+                  <a:srgbClr val="FFFFFF"/>
                 </a:solidFill>
                 <a:latin typeface="Source Sans Pro" pitchFamily="34" charset="0"/>
                 <a:ea typeface="Source Sans Pro" pitchFamily="34" charset="-122"/>
                 <a:cs typeface="Source Sans Pro" pitchFamily="34" charset="-120"/>
               </a:rPr>
-              <a:t>"Piloto en su municipio" lo baja de nivel. Él diseña estándares federales.</a:t>
+              <a:t>Puede bajar la conversación de política pública nacional a implementación local si se usa demasiado pronto.</a:t>
             </a:r>
             <a:endParaRPr lang="en-US" sz="1100" dirty="0"/>
           </a:p>
@@ -5310,6 +5351,7 @@
         <a:solidFill>
           <a:srgbClr val="1B1A1B"/>
         </a:solidFill>
+        <a:effectLst/>
       </p:bgPr>
     </p:bg>
     <p:spTree>
@@ -5347,11 +5389,11 @@
           <a:bodyPr wrap="square" lIns="0" tIns="0" rIns="0" bIns="0" rtlCol="0" anchor="ctr"/>
           <a:lstStyle/>
           <a:p>
-            <a:pPr indent="0" marL="0">
-              <a:buNone/>
-            </a:pPr>
-            <a:r>
-              <a:rPr lang="en-US" sz="1000" b="1" spc="400" kern="0" dirty="0">
+            <a:pPr marL="0" indent="0">
+              <a:buNone/>
+            </a:pPr>
+            <a:r>
+              <a:rPr lang="en-US" sz="1000" b="1" kern="0" spc="400" dirty="0">
                 <a:solidFill>
                   <a:srgbClr val="A0A0A0"/>
                 </a:solidFill>
@@ -5386,7 +5428,7 @@
           <a:bodyPr wrap="square" lIns="0" tIns="0" rIns="0" bIns="0" rtlCol="0" anchor="ctr"/>
           <a:lstStyle/>
           <a:p>
-            <a:pPr indent="0" marL="0">
+            <a:pPr marL="0" indent="0">
               <a:buNone/>
             </a:pPr>
             <a:r>
@@ -5445,7 +5487,7 @@
           <a:bodyPr wrap="square" lIns="0" tIns="0" rIns="0" bIns="0" rtlCol="0" anchor="ctr"/>
           <a:lstStyle/>
           <a:p>
-            <a:pPr algn="ctr" indent="0" marL="0">
+            <a:pPr marL="0" indent="0" algn="ctr">
               <a:buNone/>
             </a:pPr>
             <a:r>
@@ -5484,7 +5526,7 @@
           <a:bodyPr wrap="square" lIns="0" tIns="0" rIns="0" bIns="0" rtlCol="0" anchor="ctr"/>
           <a:lstStyle/>
           <a:p>
-            <a:pPr indent="0" marL="0">
+            <a:pPr marL="0" indent="0">
               <a:buNone/>
             </a:pPr>
             <a:r>
@@ -5523,11 +5565,11 @@
           <a:bodyPr wrap="square" lIns="0" tIns="0" rIns="0" bIns="0" rtlCol="0" anchor="ctr"/>
           <a:lstStyle/>
           <a:p>
-            <a:pPr indent="0" marL="0">
-              <a:buNone/>
-            </a:pPr>
-            <a:r>
-              <a:rPr lang="en-US" sz="1100" dirty="0">
+            <a:pPr marL="0" indent="0">
+              <a:buNone/>
+            </a:pPr>
+            <a:r>
+              <a:rPr lang="es-ES" sz="1100">
                 <a:solidFill>
                   <a:srgbClr val="A0A0A0"/>
                 </a:solidFill>
@@ -5535,7 +5577,7 @@
                 <a:ea typeface="Source Sans Pro" pitchFamily="34" charset="-122"/>
                 <a:cs typeface="Source Sans Pro" pitchFamily="34" charset="-120"/>
               </a:rPr>
-              <a:t>Presentación breve de Ábargon como constructores de plataformas digitales de gobierno. SIN mencionar Bache 24. Pregunta abierta sobre la ATDT.</a:t>
+              <a:t>Presentación breve de Ábargon como constructores de plataformas digitales de gobierno. SIN mencionar Bache 24. Pregunta abierta sobre política digital, estándares y modelos replicables.</a:t>
             </a:r>
             <a:endParaRPr lang="en-US" sz="1100" dirty="0"/>
           </a:p>
@@ -5582,7 +5624,7 @@
           <a:bodyPr wrap="square" lIns="0" tIns="0" rIns="0" bIns="0" rtlCol="0" anchor="ctr"/>
           <a:lstStyle/>
           <a:p>
-            <a:pPr algn="ctr" indent="0" marL="0">
+            <a:pPr marL="0" indent="0" algn="ctr">
               <a:buNone/>
             </a:pPr>
             <a:r>
@@ -5621,7 +5663,7 @@
           <a:bodyPr wrap="square" lIns="0" tIns="0" rIns="0" bIns="0" rtlCol="0" anchor="ctr"/>
           <a:lstStyle/>
           <a:p>
-            <a:pPr indent="0" marL="0">
+            <a:pPr marL="0" indent="0">
               <a:buNone/>
             </a:pPr>
             <a:r>
@@ -5660,11 +5702,11 @@
           <a:bodyPr wrap="square" lIns="0" tIns="0" rIns="0" bIns="0" rtlCol="0" anchor="ctr"/>
           <a:lstStyle/>
           <a:p>
-            <a:pPr indent="0" marL="0">
-              <a:buNone/>
-            </a:pPr>
-            <a:r>
-              <a:rPr lang="en-US" sz="1100" dirty="0">
+            <a:pPr marL="0" indent="0">
+              <a:buNone/>
+            </a:pPr>
+            <a:r>
+              <a:rPr lang="es-ES" sz="1100">
                 <a:solidFill>
                   <a:srgbClr val="A0A0A0"/>
                 </a:solidFill>
@@ -5672,7 +5714,7 @@
                 <a:ea typeface="Source Sans Pro" pitchFamily="34" charset="-122"/>
                 <a:cs typeface="Source Sans Pro" pitchFamily="34" charset="-120"/>
               </a:rPr>
-              <a:t>Escuchar. Prioridades de la ATDT. Relación federal-municipal. Uso de IA en gestión pública. Participación ciudadana digital.</a:t>
+              <a:t>Escuchar. Prioridades de la ATDT. Estándares federales. Relación federal-municipal. Uso de IA en gestión pública. Participación ciudadana digital.</a:t>
             </a:r>
             <a:endParaRPr lang="en-US" sz="1100" dirty="0"/>
           </a:p>
@@ -5719,7 +5761,7 @@
           <a:bodyPr wrap="square" lIns="0" tIns="0" rIns="0" bIns="0" rtlCol="0" anchor="ctr"/>
           <a:lstStyle/>
           <a:p>
-            <a:pPr algn="ctr" indent="0" marL="0">
+            <a:pPr marL="0" indent="0" algn="ctr">
               <a:buNone/>
             </a:pPr>
             <a:r>
@@ -5758,7 +5800,7 @@
           <a:bodyPr wrap="square" lIns="0" tIns="0" rIns="0" bIns="0" rtlCol="0" anchor="ctr"/>
           <a:lstStyle/>
           <a:p>
-            <a:pPr indent="0" marL="0">
+            <a:pPr marL="0" indent="0">
               <a:buNone/>
             </a:pPr>
             <a:r>
@@ -5797,7 +5839,7 @@
           <a:bodyPr wrap="square" lIns="0" tIns="0" rIns="0" bIns="0" rtlCol="0" anchor="ctr"/>
           <a:lstStyle/>
           <a:p>
-            <a:pPr indent="0" marL="0">
+            <a:pPr marL="0" indent="0">
               <a:buNone/>
             </a:pPr>
             <a:r>
@@ -5809,7 +5851,7 @@
                 <a:ea typeface="Source Sans Pro" pitchFamily="34" charset="-122"/>
                 <a:cs typeface="Source Sans Pro" pitchFamily="34" charset="-120"/>
               </a:rPr>
-              <a:t>Mostrar 3-4 pantallas como caso de uso (slides 4, 7, 12, 20 del PDF). Enfatizar: datos desde el origen, IA que prioriza, modelo replicable.</a:t>
+              <a:t>Mostrar pantallas seleccionadas como caso de uso (slides 4, 7, 12 y, si aplica, 13-14). Enfatizar: datos desde el origen, IA que prioriza, criterios replicables.</a:t>
             </a:r>
             <a:endParaRPr lang="en-US" sz="1100" dirty="0"/>
           </a:p>
@@ -5856,7 +5898,7 @@
           <a:bodyPr wrap="square" lIns="0" tIns="0" rIns="0" bIns="0" rtlCol="0" anchor="ctr"/>
           <a:lstStyle/>
           <a:p>
-            <a:pPr algn="ctr" indent="0" marL="0">
+            <a:pPr marL="0" indent="0" algn="ctr">
               <a:buNone/>
             </a:pPr>
             <a:r>
@@ -5895,7 +5937,7 @@
           <a:bodyPr wrap="square" lIns="0" tIns="0" rIns="0" bIns="0" rtlCol="0" anchor="ctr"/>
           <a:lstStyle/>
           <a:p>
-            <a:pPr indent="0" marL="0">
+            <a:pPr marL="0" indent="0">
               <a:buNone/>
             </a:pPr>
             <a:r>
@@ -5934,11 +5976,11 @@
           <a:bodyPr wrap="square" lIns="0" tIns="0" rIns="0" bIns="0" rtlCol="0" anchor="ctr"/>
           <a:lstStyle/>
           <a:p>
-            <a:pPr indent="0" marL="0">
-              <a:buNone/>
-            </a:pPr>
-            <a:r>
-              <a:rPr lang="en-US" sz="1100" dirty="0">
+            <a:pPr marL="0" indent="0">
+              <a:buNone/>
+            </a:pPr>
+            <a:r>
+              <a:rPr lang="es-ES" sz="1100">
                 <a:solidFill>
                   <a:srgbClr val="A0A0A0"/>
                 </a:solidFill>
@@ -5946,7 +5988,7 @@
                 <a:ea typeface="Source Sans Pro" pitchFamily="34" charset="-122"/>
                 <a:cs typeface="Source Sans Pro" pitchFamily="34" charset="-120"/>
               </a:rPr>
-              <a:t>Ofrecer documento de propuesta adaptado a nivel federal. Pedir conexión con el área de la ATDT que define estándares tecnológicos. Acordar siguiente paso concreto.</a:t>
+              <a:t>Ofrecer nota ejecutiva sobre estándar replicable bajo el marco ATDT. Pedir conexión con el área que define criterios, adopción y estándares tecnológicos.</a:t>
             </a:r>
             <a:endParaRPr lang="en-US" sz="1100" dirty="0"/>
           </a:p>
@@ -5968,6 +6010,7 @@
         <a:solidFill>
           <a:srgbClr val="1B1A1B"/>
         </a:solidFill>
+        <a:effectLst/>
       </p:bgPr>
     </p:bg>
     <p:spTree>
@@ -6005,11 +6048,11 @@
           <a:bodyPr wrap="square" lIns="0" tIns="0" rIns="0" bIns="0" rtlCol="0" anchor="ctr"/>
           <a:lstStyle/>
           <a:p>
-            <a:pPr indent="0" marL="0">
-              <a:buNone/>
-            </a:pPr>
-            <a:r>
-              <a:rPr lang="en-US" sz="1000" b="1" spc="400" kern="0" dirty="0">
+            <a:pPr marL="0" indent="0">
+              <a:buNone/>
+            </a:pPr>
+            <a:r>
+              <a:rPr lang="en-US" sz="1000" b="1" kern="0" spc="400" dirty="0">
                 <a:solidFill>
                   <a:srgbClr val="A0A0A0"/>
                 </a:solidFill>
@@ -6044,7 +6087,7 @@
           <a:bodyPr wrap="square" lIns="0" tIns="0" rIns="0" bIns="0" rtlCol="0" anchor="ctr"/>
           <a:lstStyle/>
           <a:p>
-            <a:pPr indent="0" marL="0">
+            <a:pPr marL="0" indent="0">
               <a:buNone/>
             </a:pPr>
             <a:r>
@@ -6083,7 +6126,7 @@
           <a:bodyPr wrap="square" lIns="0" tIns="0" rIns="0" bIns="0" rtlCol="0" anchor="ctr"/>
           <a:lstStyle/>
           <a:p>
-            <a:pPr indent="0" marL="0">
+            <a:pPr marL="0" indent="0">
               <a:buNone/>
             </a:pPr>
             <a:r>
@@ -6122,7 +6165,7 @@
           <a:bodyPr wrap="square" lIns="0" tIns="0" rIns="0" bIns="0" rtlCol="0" anchor="ctr"/>
           <a:lstStyle/>
           <a:p>
-            <a:pPr indent="0" marL="0">
+            <a:pPr marL="0" indent="0">
               <a:buNone/>
             </a:pPr>
             <a:r>
@@ -6161,7 +6204,7 @@
           <a:bodyPr wrap="square" lIns="0" tIns="0" rIns="0" bIns="0" rtlCol="0" anchor="ctr"/>
           <a:lstStyle/>
           <a:p>
-            <a:pPr indent="0" marL="0">
+            <a:pPr marL="0" indent="0">
               <a:buNone/>
             </a:pPr>
             <a:r>
@@ -6200,7 +6243,7 @@
           <a:bodyPr wrap="square" lIns="0" tIns="0" rIns="0" bIns="0" rtlCol="0" anchor="ctr"/>
           <a:lstStyle/>
           <a:p>
-            <a:pPr indent="0" marL="0">
+            <a:pPr marL="0" indent="0">
               <a:buNone/>
             </a:pPr>
             <a:r>
@@ -6239,11 +6282,11 @@
           <a:bodyPr wrap="square" lIns="0" tIns="0" rIns="0" bIns="0" rtlCol="0" anchor="ctr"/>
           <a:lstStyle/>
           <a:p>
-            <a:pPr indent="0" marL="0">
-              <a:buNone/>
-            </a:pPr>
-            <a:r>
-              <a:rPr lang="en-US" sz="1200" dirty="0">
+            <a:pPr marL="0" indent="0">
+              <a:buNone/>
+            </a:pPr>
+            <a:r>
+              <a:rPr lang="es-ES" sz="1200">
                 <a:solidFill>
                   <a:srgbClr val="FFFFFF"/>
                 </a:solidFill>
@@ -6251,7 +6294,7 @@
                 <a:ea typeface="Source Sans Pro" pitchFamily="34" charset="-122"/>
                 <a:cs typeface="Source Sans Pro" pitchFamily="34" charset="-120"/>
               </a:rPr>
-              <a:t>¿La visión es que cada municipio tenga su plataforma, o buscan un estándar federal que se adopte localmente?</a:t>
+              <a:t>¿La visión es que cada municipio tenga su plataforma, o buscan un estándar federal que pueda adoptarse localmente?</a:t>
             </a:r>
             <a:endParaRPr lang="en-US" sz="1200" dirty="0"/>
           </a:p>
@@ -6278,11 +6321,11 @@
           <a:bodyPr wrap="square" lIns="0" tIns="0" rIns="0" bIns="0" rtlCol="0" anchor="ctr"/>
           <a:lstStyle/>
           <a:p>
-            <a:pPr indent="0" marL="0">
-              <a:buNone/>
-            </a:pPr>
-            <a:r>
-              <a:rPr lang="en-US" sz="1000" i="1" dirty="0">
+            <a:pPr marL="0" indent="0">
+              <a:buNone/>
+            </a:pPr>
+            <a:r>
+              <a:rPr lang="es-ES" sz="1000" i="1">
                 <a:solidFill>
                   <a:srgbClr val="A0A0A0"/>
                 </a:solidFill>
@@ -6290,7 +6333,7 @@
                 <a:ea typeface="Calibri" pitchFamily="34" charset="-122"/>
                 <a:cs typeface="Calibri" pitchFamily="34" charset="-120"/>
               </a:rPr>
-              <a:t>La respuesta define si somos relevantes a nivel de infraestructura o de implementación.</a:t>
+              <a:t>La respuesta define si somos relevantes a nivel de política, referencia técnica o implementación.</a:t>
             </a:r>
             <a:endParaRPr lang="en-US" sz="1000" dirty="0"/>
           </a:p>
@@ -6317,7 +6360,7 @@
           <a:bodyPr wrap="square" lIns="0" tIns="0" rIns="0" bIns="0" rtlCol="0" anchor="ctr"/>
           <a:lstStyle/>
           <a:p>
-            <a:pPr indent="0" marL="0">
+            <a:pPr marL="0" indent="0">
               <a:buNone/>
             </a:pPr>
             <a:r>
@@ -6356,7 +6399,7 @@
           <a:bodyPr wrap="square" lIns="0" tIns="0" rIns="0" bIns="0" rtlCol="0" anchor="ctr"/>
           <a:lstStyle/>
           <a:p>
-            <a:pPr indent="0" marL="0">
+            <a:pPr marL="0" indent="0">
               <a:buNone/>
             </a:pPr>
             <a:r>
@@ -6395,7 +6438,7 @@
           <a:bodyPr wrap="square" lIns="0" tIns="0" rIns="0" bIns="0" rtlCol="0" anchor="ctr"/>
           <a:lstStyle/>
           <a:p>
-            <a:pPr indent="0" marL="0">
+            <a:pPr marL="0" indent="0">
               <a:buNone/>
             </a:pPr>
             <a:r>
@@ -6434,7 +6477,7 @@
           <a:bodyPr wrap="square" lIns="0" tIns="0" rIns="0" bIns="0" rtlCol="0" anchor="ctr"/>
           <a:lstStyle/>
           <a:p>
-            <a:pPr indent="0" marL="0">
+            <a:pPr marL="0" indent="0">
               <a:buNone/>
             </a:pPr>
             <a:r>
@@ -6473,7 +6516,7 @@
           <a:bodyPr wrap="square" lIns="0" tIns="0" rIns="0" bIns="0" rtlCol="0" anchor="ctr"/>
           <a:lstStyle/>
           <a:p>
-            <a:pPr indent="0" marL="0">
+            <a:pPr marL="0" indent="0">
               <a:buNone/>
             </a:pPr>
             <a:r>
@@ -6512,7 +6555,7 @@
           <a:bodyPr wrap="square" lIns="0" tIns="0" rIns="0" bIns="0" rtlCol="0" anchor="ctr"/>
           <a:lstStyle/>
           <a:p>
-            <a:pPr indent="0" marL="0">
+            <a:pPr marL="0" indent="0">
               <a:buNone/>
             </a:pPr>
             <a:r>
@@ -6551,7 +6594,7 @@
           <a:bodyPr wrap="square" lIns="0" tIns="0" rIns="0" bIns="0" rtlCol="0" anchor="ctr"/>
           <a:lstStyle/>
           <a:p>
-            <a:pPr indent="0" marL="0">
+            <a:pPr marL="0" indent="0">
               <a:buNone/>
             </a:pPr>
             <a:r>
@@ -6590,11 +6633,11 @@
           <a:bodyPr wrap="square" lIns="0" tIns="0" rIns="0" bIns="0" rtlCol="0" anchor="ctr"/>
           <a:lstStyle/>
           <a:p>
-            <a:pPr indent="0" marL="0">
-              <a:buNone/>
-            </a:pPr>
-            <a:r>
-              <a:rPr lang="en-US" sz="1200" dirty="0">
+            <a:pPr marL="0" indent="0">
+              <a:buNone/>
+            </a:pPr>
+            <a:r>
+              <a:rPr lang="es-ES" sz="1200">
                 <a:solidFill>
                   <a:srgbClr val="FFFFFF"/>
                 </a:solidFill>
@@ -6602,7 +6645,7 @@
                 <a:ea typeface="Source Sans Pro" pitchFamily="34" charset="-122"/>
                 <a:cs typeface="Source Sans Pro" pitchFamily="34" charset="-120"/>
               </a:rPr>
-              <a:t>¿Existe apertura para modelos de colaboración público-privada en este espacio?</a:t>
+              <a:t>¿Existe apertura para modelos de colaboración público-privada que ayuden a convertir experiencia probada en lineamientos replicables?</a:t>
             </a:r>
             <a:endParaRPr lang="en-US" sz="1200" dirty="0"/>
           </a:p>
@@ -6629,11 +6672,11 @@
           <a:bodyPr wrap="square" lIns="0" tIns="0" rIns="0" bIns="0" rtlCol="0" anchor="ctr"/>
           <a:lstStyle/>
           <a:p>
-            <a:pPr indent="0" marL="0">
-              <a:buNone/>
-            </a:pPr>
-            <a:r>
-              <a:rPr lang="en-US" sz="1000" i="1" dirty="0">
+            <a:pPr marL="0" indent="0">
+              <a:buNone/>
+            </a:pPr>
+            <a:r>
+              <a:rPr lang="es-ES" sz="1000" i="1">
                 <a:solidFill>
                   <a:srgbClr val="A0A0A0"/>
                 </a:solidFill>
@@ -6641,7 +6684,7 @@
                 <a:ea typeface="Calibri" pitchFamily="34" charset="-122"/>
                 <a:cs typeface="Calibri" pitchFamily="34" charset="-120"/>
               </a:rPr>
-              <a:t>Valida si hay ruta comercial real antes de invertir más tiempo.</a:t>
+              <a:t>Valida si hay ruta real antes de invertir más tiempo.</a:t>
             </a:r>
             <a:endParaRPr lang="en-US" sz="1000" dirty="0"/>
           </a:p>
@@ -6663,6 +6706,7 @@
         <a:solidFill>
           <a:srgbClr val="1B1A1B"/>
         </a:solidFill>
+        <a:effectLst/>
       </p:bgPr>
     </p:bg>
     <p:spTree>
@@ -6700,11 +6744,11 @@
           <a:bodyPr wrap="square" lIns="0" tIns="0" rIns="0" bIns="0" rtlCol="0" anchor="ctr"/>
           <a:lstStyle/>
           <a:p>
-            <a:pPr indent="0" marL="0">
-              <a:buNone/>
-            </a:pPr>
-            <a:r>
-              <a:rPr lang="en-US" sz="1000" b="1" spc="400" kern="0" dirty="0">
+            <a:pPr marL="0" indent="0">
+              <a:buNone/>
+            </a:pPr>
+            <a:r>
+              <a:rPr lang="en-US" sz="1000" b="1" kern="0" spc="400" dirty="0">
                 <a:solidFill>
                   <a:srgbClr val="A0A0A0"/>
                 </a:solidFill>
@@ -6737,7 +6781,7 @@
           </a:solidFill>
           <a:ln/>
           <a:effectLst>
-            <a:outerShdw sx="100000" sy="100000" kx="0" ky="0" algn="bl" rotWithShape="0" blurRad="101600" dist="38100" dir="8100000">
+            <a:outerShdw blurRad="101600" dist="38100" dir="8100000" algn="bl" rotWithShape="0">
               <a:srgbClr val="000000">
                 <a:alpha val="30000"/>
               </a:srgbClr>
@@ -6786,11 +6830,11 @@
           <a:bodyPr wrap="square" lIns="0" tIns="0" rIns="0" bIns="0" rtlCol="0" anchor="ctr"/>
           <a:lstStyle/>
           <a:p>
-            <a:pPr indent="0" marL="0">
-              <a:buNone/>
-            </a:pPr>
-            <a:r>
-              <a:rPr lang="en-US" sz="1600" i="1" dirty="0">
+            <a:pPr marL="0" indent="0">
+              <a:buNone/>
+            </a:pPr>
+            <a:r>
+              <a:rPr lang="es-ES" sz="1600" i="1">
                 <a:solidFill>
                   <a:srgbClr val="FFFFFF"/>
                 </a:solidFill>
@@ -6798,7 +6842,7 @@
                 <a:ea typeface="Source Sans Pro" pitchFamily="34" charset="-122"/>
                 <a:cs typeface="Source Sans Pro" pitchFamily="34" charset="-120"/>
               </a:rPr>
-              <a:t>"No venimos a hablar de baches — venimos porque creemos que la infraestructura digital para gestión urbana ya existe, la hemos construido, y lo que falta es que alguien con la visión federal la adopte como estándar. Eso es lo que la ATDT puede hacer."</a:t>
+              <a:t>"No venimos a hablar de baches como problema aislado. Venimos porque creemos que la infraestructura digital para gestión urbana ya existe, la hemos construido, y puede traducirse en estándares, criterios y modelos replicables para gobiernos locales. Eso es lo que la ATDT puede habilitar a escala nacional."</a:t>
             </a:r>
             <a:endParaRPr lang="en-US" sz="1600" dirty="0"/>
           </a:p>
@@ -6825,11 +6869,11 @@
           <a:bodyPr wrap="square" lIns="0" tIns="0" rIns="0" bIns="0" rtlCol="0" anchor="ctr"/>
           <a:lstStyle/>
           <a:p>
-            <a:pPr indent="0" marL="0">
-              <a:buNone/>
-            </a:pPr>
-            <a:r>
-              <a:rPr lang="en-US" sz="1000" b="1" spc="400" kern="0" dirty="0">
+            <a:pPr marL="0" indent="0">
+              <a:buNone/>
+            </a:pPr>
+            <a:r>
+              <a:rPr lang="en-US" sz="1000" b="1" kern="0" spc="400" dirty="0">
                 <a:solidFill>
                   <a:srgbClr val="A0A0A0"/>
                 </a:solidFill>
@@ -6862,7 +6906,7 @@
           </a:solidFill>
           <a:ln/>
           <a:effectLst>
-            <a:outerShdw sx="100000" sy="100000" kx="0" ky="0" algn="bl" rotWithShape="0" blurRad="101600" dist="38100" dir="8100000">
+            <a:outerShdw blurRad="101600" dist="38100" dir="8100000" algn="bl" rotWithShape="0">
               <a:srgbClr val="000000">
                 <a:alpha val="30000"/>
               </a:srgbClr>
@@ -6891,11 +6935,11 @@
           <a:bodyPr wrap="square" lIns="0" tIns="0" rIns="0" bIns="0" rtlCol="0" anchor="ctr"/>
           <a:lstStyle/>
           <a:p>
-            <a:pPr indent="0" marL="0">
-              <a:buNone/>
-            </a:pPr>
-            <a:r>
-              <a:rPr lang="en-US" sz="900" b="1" spc="300" kern="0" dirty="0">
+            <a:pPr marL="0" indent="0">
+              <a:buNone/>
+            </a:pPr>
+            <a:r>
+              <a:rPr lang="en-US" sz="900" b="1" kern="0" spc="300" dirty="0">
                 <a:solidFill>
                   <a:srgbClr val="4CAF50"/>
                 </a:solidFill>
@@ -6930,11 +6974,11 @@
           <a:bodyPr wrap="square" lIns="0" tIns="0" rIns="0" bIns="0" rtlCol="0" anchor="ctr"/>
           <a:lstStyle/>
           <a:p>
-            <a:pPr indent="0" marL="0">
-              <a:buNone/>
-            </a:pPr>
-            <a:r>
-              <a:rPr lang="en-US" sz="1100" dirty="0">
+            <a:pPr marL="0" indent="0">
+              <a:buNone/>
+            </a:pPr>
+            <a:r>
+              <a:rPr lang="es-ES" sz="1100">
                 <a:solidFill>
                   <a:srgbClr val="FFFFFF"/>
                 </a:solidFill>
@@ -6942,7 +6986,7 @@
                 <a:ea typeface="Source Sans Pro" pitchFamily="34" charset="-122"/>
                 <a:cs typeface="Source Sans Pro" pitchFamily="34" charset="-120"/>
               </a:rPr>
-              <a:t>"¿Tiene sentido que preparemos un documento de cómo esta plataforma podría funcionar como estándar replicable bajo el paraguas de la ATDT?"</a:t>
+              <a:t>"¿Tiene sentido que preparemos una nota ejecutiva sobre cómo esta experiencia podría traducirse en un estándar de gestión digital replicable para municipios, alineado con la agenda de la ATDT?"</a:t>
             </a:r>
             <a:endParaRPr lang="en-US" sz="1100" dirty="0"/>
           </a:p>
@@ -6967,7 +7011,7 @@
           </a:solidFill>
           <a:ln/>
           <a:effectLst>
-            <a:outerShdw sx="100000" sy="100000" kx="0" ky="0" algn="bl" rotWithShape="0" blurRad="101600" dist="38100" dir="8100000">
+            <a:outerShdw blurRad="101600" dist="38100" dir="8100000" algn="bl" rotWithShape="0">
               <a:srgbClr val="000000">
                 <a:alpha val="30000"/>
               </a:srgbClr>
@@ -6996,11 +7040,11 @@
           <a:bodyPr wrap="square" lIns="0" tIns="0" rIns="0" bIns="0" rtlCol="0" anchor="ctr"/>
           <a:lstStyle/>
           <a:p>
-            <a:pPr indent="0" marL="0">
-              <a:buNone/>
-            </a:pPr>
-            <a:r>
-              <a:rPr lang="en-US" sz="900" b="1" spc="300" kern="0" dirty="0">
+            <a:pPr marL="0" indent="0">
+              <a:buNone/>
+            </a:pPr>
+            <a:r>
+              <a:rPr lang="en-US" sz="900" b="1" kern="0" spc="300" dirty="0">
                 <a:solidFill>
                   <a:srgbClr val="C8D8F8"/>
                 </a:solidFill>
@@ -7035,11 +7079,11 @@
           <a:bodyPr wrap="square" lIns="0" tIns="0" rIns="0" bIns="0" rtlCol="0" anchor="ctr"/>
           <a:lstStyle/>
           <a:p>
-            <a:pPr indent="0" marL="0">
-              <a:buNone/>
-            </a:pPr>
-            <a:r>
-              <a:rPr lang="en-US" sz="1100" dirty="0">
+            <a:pPr marL="0" indent="0">
+              <a:buNone/>
+            </a:pPr>
+            <a:r>
+              <a:rPr lang="es-ES" sz="1100">
                 <a:solidFill>
                   <a:srgbClr val="FFFFFF"/>
                 </a:solidFill>
@@ -7047,7 +7091,7 @@
                 <a:ea typeface="Source Sans Pro" pitchFamily="34" charset="-122"/>
                 <a:cs typeface="Source Sans Pro" pitchFamily="34" charset="-120"/>
               </a:rPr>
-              <a:t>Que nos conecte con el área operativa correcta dentro de la ATDT — la que define estándares tecnológicos para municipios.</a:t>
+              <a:t>Que nos conecte con el área correcta dentro de la ATDT — la que define estándares tecnológicos, criterios de adopción y modelos de implementación digital para gobiernos locales.</a:t>
             </a:r>
             <a:endParaRPr lang="en-US" sz="1100" dirty="0"/>
           </a:p>
@@ -7074,7 +7118,7 @@
           <a:bodyPr wrap="square" lIns="0" tIns="0" rIns="0" bIns="0" rtlCol="0" anchor="ctr"/>
           <a:lstStyle/>
           <a:p>
-            <a:pPr algn="ctr" indent="0" marL="0">
+            <a:pPr marL="0" indent="0" algn="ctr">
               <a:buNone/>
             </a:pPr>
             <a:r>
@@ -7393,4 +7437,299 @@
     </a:ext>
   </a:extLst>
 </a:theme>
+</file>
+
+<file path=ppt/theme/theme2.xml><?xml version="1.0" encoding="utf-8"?>
+<a:theme xmlns:a="http://schemas.openxmlformats.org/drawingml/2006/main" name="Office Theme">
+  <a:themeElements>
+    <a:clrScheme name="Office">
+      <a:dk1>
+        <a:sysClr val="windowText" lastClr="000000"/>
+      </a:dk1>
+      <a:lt1>
+        <a:sysClr val="window" lastClr="FFFFFF"/>
+      </a:lt1>
+      <a:dk2>
+        <a:srgbClr val="44546A"/>
+      </a:dk2>
+      <a:lt2>
+        <a:srgbClr val="E7E6E6"/>
+      </a:lt2>
+      <a:accent1>
+        <a:srgbClr val="4472C4"/>
+      </a:accent1>
+      <a:accent2>
+        <a:srgbClr val="ED7D31"/>
+      </a:accent2>
+      <a:accent3>
+        <a:srgbClr val="A5A5A5"/>
+      </a:accent3>
+      <a:accent4>
+        <a:srgbClr val="FFC000"/>
+      </a:accent4>
+      <a:accent5>
+        <a:srgbClr val="5B9BD5"/>
+      </a:accent5>
+      <a:accent6>
+        <a:srgbClr val="70AD47"/>
+      </a:accent6>
+      <a:hlink>
+        <a:srgbClr val="0563C1"/>
+      </a:hlink>
+      <a:folHlink>
+        <a:srgbClr val="954F72"/>
+      </a:folHlink>
+    </a:clrScheme>
+    <a:fontScheme name="Office">
+      <a:majorFont>
+        <a:latin typeface="Calibri Light" panose="020F0302020204030204"/>
+        <a:ea typeface=""/>
+        <a:cs typeface=""/>
+        <a:font script="Jpan" typeface="游ゴシック Light"/>
+        <a:font script="Hang" typeface="맑은 고딕"/>
+        <a:font script="Hans" typeface="等线 Light"/>
+        <a:font script="Hant" typeface="新細明體"/>
+        <a:font script="Arab" typeface="Times New Roman"/>
+        <a:font script="Hebr" typeface="Times New Roman"/>
+        <a:font script="Thai" typeface="Angsana New"/>
+        <a:font script="Ethi" typeface="Nyala"/>
+        <a:font script="Beng" typeface="Vrinda"/>
+        <a:font script="Gujr" typeface="Shruti"/>
+        <a:font script="Khmr" typeface="MoolBoran"/>
+        <a:font script="Knda" typeface="Tunga"/>
+        <a:font script="Guru" typeface="Raavi"/>
+        <a:font script="Cans" typeface="Euphemia"/>
+        <a:font script="Cher" typeface="Plantagenet Cherokee"/>
+        <a:font script="Yiii" typeface="Microsoft Yi Baiti"/>
+        <a:font script="Tibt" typeface="Microsoft Himalaya"/>
+        <a:font script="Thaa" typeface="MV Boli"/>
+        <a:font script="Deva" typeface="Mangal"/>
+        <a:font script="Telu" typeface="Gautami"/>
+        <a:font script="Taml" typeface="Latha"/>
+        <a:font script="Syrc" typeface="Estrangelo Edessa"/>
+        <a:font script="Orya" typeface="Kalinga"/>
+        <a:font script="Mlym" typeface="Kartika"/>
+        <a:font script="Laoo" typeface="DokChampa"/>
+        <a:font script="Sinh" typeface="Iskoola Pota"/>
+        <a:font script="Mong" typeface="Mongolian Baiti"/>
+        <a:font script="Viet" typeface="Times New Roman"/>
+        <a:font script="Uigh" typeface="Microsoft Uighur"/>
+        <a:font script="Geor" typeface="Sylfaen"/>
+        <a:font script="Armn" typeface="Arial"/>
+        <a:font script="Bugi" typeface="Leelawadee UI"/>
+        <a:font script="Bopo" typeface="Microsoft JhengHei"/>
+        <a:font script="Java" typeface="Javanese Text"/>
+        <a:font script="Lisu" typeface="Segoe UI"/>
+        <a:font script="Mymr" typeface="Myanmar Text"/>
+        <a:font script="Nkoo" typeface="Ebrima"/>
+        <a:font script="Olck" typeface="Nirmala UI"/>
+        <a:font script="Osma" typeface="Ebrima"/>
+        <a:font script="Phag" typeface="Phagspa"/>
+        <a:font script="Syrn" typeface="Estrangelo Edessa"/>
+        <a:font script="Syrj" typeface="Estrangelo Edessa"/>
+        <a:font script="Syre" typeface="Estrangelo Edessa"/>
+        <a:font script="Sora" typeface="Nirmala UI"/>
+        <a:font script="Tale" typeface="Microsoft Tai Le"/>
+        <a:font script="Talu" typeface="Microsoft New Tai Lue"/>
+        <a:font script="Tfng" typeface="Ebrima"/>
+      </a:majorFont>
+      <a:minorFont>
+        <a:latin typeface="Calibri" panose="020F0502020204030204"/>
+        <a:ea typeface=""/>
+        <a:cs typeface=""/>
+        <a:font script="Jpan" typeface="游ゴシック"/>
+        <a:font script="Hang" typeface="맑은 고딕"/>
+        <a:font script="Hans" typeface="等线"/>
+        <a:font script="Hant" typeface="新細明體"/>
+        <a:font script="Arab" typeface="Arial"/>
+        <a:font script="Hebr" typeface="Arial"/>
+        <a:font script="Thai" typeface="Cordia New"/>
+        <a:font script="Ethi" typeface="Nyala"/>
+        <a:font script="Beng" typeface="Vrinda"/>
+        <a:font script="Gujr" typeface="Shruti"/>
+        <a:font script="Khmr" typeface="DaunPenh"/>
+        <a:font script="Knda" typeface="Tunga"/>
+        <a:font script="Guru" typeface="Raavi"/>
+        <a:font script="Cans" typeface="Euphemia"/>
+        <a:font script="Cher" typeface="Plantagenet Cherokee"/>
+        <a:font script="Yiii" typeface="Microsoft Yi Baiti"/>
+        <a:font script="Tibt" typeface="Microsoft Himalaya"/>
+        <a:font script="Thaa" typeface="MV Boli"/>
+        <a:font script="Deva" typeface="Mangal"/>
+        <a:font script="Telu" typeface="Gautami"/>
+        <a:font script="Taml" typeface="Latha"/>
+        <a:font script="Syrc" typeface="Estrangelo Edessa"/>
+        <a:font script="Orya" typeface="Kalinga"/>
+        <a:font script="Mlym" typeface="Kartika"/>
+        <a:font script="Laoo" typeface="DokChampa"/>
+        <a:font script="Sinh" typeface="Iskoola Pota"/>
+        <a:font script="Mong" typeface="Mongolian Baiti"/>
+        <a:font script="Viet" typeface="Arial"/>
+        <a:font script="Uigh" typeface="Microsoft Uighur"/>
+        <a:font script="Geor" typeface="Sylfaen"/>
+        <a:font script="Armn" typeface="Arial"/>
+        <a:font script="Bugi" typeface="Leelawadee UI"/>
+        <a:font script="Bopo" typeface="Microsoft JhengHei"/>
+        <a:font script="Java" typeface="Javanese Text"/>
+        <a:font script="Lisu" typeface="Segoe UI"/>
+        <a:font script="Mymr" typeface="Myanmar Text"/>
+        <a:font script="Nkoo" typeface="Ebrima"/>
+        <a:font script="Olck" typeface="Nirmala UI"/>
+        <a:font script="Osma" typeface="Ebrima"/>
+        <a:font script="Phag" typeface="Phagspa"/>
+        <a:font script="Syrn" typeface="Estrangelo Edessa"/>
+        <a:font script="Syrj" typeface="Estrangelo Edessa"/>
+        <a:font script="Syre" typeface="Estrangelo Edessa"/>
+        <a:font script="Sora" typeface="Nirmala UI"/>
+        <a:font script="Tale" typeface="Microsoft Tai Le"/>
+        <a:font script="Talu" typeface="Microsoft New Tai Lue"/>
+        <a:font script="Tfng" typeface="Ebrima"/>
+      </a:minorFont>
+    </a:fontScheme>
+    <a:fmtScheme name="Office">
+      <a:fillStyleLst>
+        <a:solidFill>
+          <a:schemeClr val="phClr"/>
+        </a:solidFill>
+        <a:gradFill rotWithShape="1">
+          <a:gsLst>
+            <a:gs pos="0">
+              <a:schemeClr val="phClr">
+                <a:lumMod val="110000"/>
+                <a:satMod val="105000"/>
+                <a:tint val="67000"/>
+              </a:schemeClr>
+            </a:gs>
+            <a:gs pos="50000">
+              <a:schemeClr val="phClr">
+                <a:lumMod val="105000"/>
+                <a:satMod val="103000"/>
+                <a:tint val="73000"/>
+              </a:schemeClr>
+            </a:gs>
+            <a:gs pos="100000">
+              <a:schemeClr val="phClr">
+                <a:lumMod val="105000"/>
+                <a:satMod val="109000"/>
+                <a:tint val="81000"/>
+              </a:schemeClr>
+            </a:gs>
+          </a:gsLst>
+          <a:lin ang="5400000" scaled="0"/>
+        </a:gradFill>
+        <a:gradFill rotWithShape="1">
+          <a:gsLst>
+            <a:gs pos="0">
+              <a:schemeClr val="phClr">
+                <a:satMod val="103000"/>
+                <a:lumMod val="102000"/>
+                <a:tint val="94000"/>
+              </a:schemeClr>
+            </a:gs>
+            <a:gs pos="50000">
+              <a:schemeClr val="phClr">
+                <a:satMod val="110000"/>
+                <a:lumMod val="100000"/>
+                <a:shade val="100000"/>
+              </a:schemeClr>
+            </a:gs>
+            <a:gs pos="100000">
+              <a:schemeClr val="phClr">
+                <a:lumMod val="99000"/>
+                <a:satMod val="120000"/>
+                <a:shade val="78000"/>
+              </a:schemeClr>
+            </a:gs>
+          </a:gsLst>
+          <a:lin ang="5400000" scaled="0"/>
+        </a:gradFill>
+      </a:fillStyleLst>
+      <a:lnStyleLst>
+        <a:ln w="6350" cap="flat" cmpd="sng" algn="ctr">
+          <a:solidFill>
+            <a:schemeClr val="phClr"/>
+          </a:solidFill>
+          <a:prstDash val="solid"/>
+          <a:miter lim="800000"/>
+        </a:ln>
+        <a:ln w="12700" cap="flat" cmpd="sng" algn="ctr">
+          <a:solidFill>
+            <a:schemeClr val="phClr"/>
+          </a:solidFill>
+          <a:prstDash val="solid"/>
+          <a:miter lim="800000"/>
+        </a:ln>
+        <a:ln w="19050" cap="flat" cmpd="sng" algn="ctr">
+          <a:solidFill>
+            <a:schemeClr val="phClr"/>
+          </a:solidFill>
+          <a:prstDash val="solid"/>
+          <a:miter lim="800000"/>
+        </a:ln>
+      </a:lnStyleLst>
+      <a:effectStyleLst>
+        <a:effectStyle>
+          <a:effectLst/>
+        </a:effectStyle>
+        <a:effectStyle>
+          <a:effectLst/>
+        </a:effectStyle>
+        <a:effectStyle>
+          <a:effectLst>
+            <a:outerShdw blurRad="57150" dist="19050" dir="5400000" algn="ctr" rotWithShape="0">
+              <a:srgbClr val="000000">
+                <a:alpha val="63000"/>
+              </a:srgbClr>
+            </a:outerShdw>
+          </a:effectLst>
+        </a:effectStyle>
+      </a:effectStyleLst>
+      <a:bgFillStyleLst>
+        <a:solidFill>
+          <a:schemeClr val="phClr"/>
+        </a:solidFill>
+        <a:solidFill>
+          <a:schemeClr val="phClr">
+            <a:tint val="95000"/>
+            <a:satMod val="170000"/>
+          </a:schemeClr>
+        </a:solidFill>
+        <a:gradFill rotWithShape="1">
+          <a:gsLst>
+            <a:gs pos="0">
+              <a:schemeClr val="phClr">
+                <a:tint val="93000"/>
+                <a:satMod val="150000"/>
+                <a:shade val="98000"/>
+                <a:lumMod val="102000"/>
+              </a:schemeClr>
+            </a:gs>
+            <a:gs pos="50000">
+              <a:schemeClr val="phClr">
+                <a:tint val="98000"/>
+                <a:satMod val="130000"/>
+                <a:shade val="90000"/>
+                <a:lumMod val="103000"/>
+              </a:schemeClr>
+            </a:gs>
+            <a:gs pos="100000">
+              <a:schemeClr val="phClr">
+                <a:shade val="63000"/>
+                <a:satMod val="120000"/>
+              </a:schemeClr>
+            </a:gs>
+          </a:gsLst>
+          <a:lin ang="5400000" scaled="0"/>
+        </a:gradFill>
+      </a:bgFillStyleLst>
+    </a:fmtScheme>
+  </a:themeElements>
+  <a:objectDefaults/>
+  <a:extraClrSchemeLst/>
+  <a:extLst>
+    <a:ext uri="{05A4C25C-085E-4340-85A3-A5531E510DB2}">
+      <thm15:themeFamily xmlns:thm15="http://schemas.microsoft.com/office/thememl/2012/main" name="Office Theme" id="{62F939B6-93AF-4DB8-9C6B-D6C7DFDC589F}" vid="{4A3C46E8-61CC-4603-A589-7422A47A8E4A}"/>
+    </a:ext>
+  </a:extLst>
+</a:theme>
 </file>
</xml_diff>